<commit_message>
Design Studio upgrade: canvas editor, AI prompt overhaul, Puter TTS, bug fixes
- Add canvas annotation component (pen, text, arrow, circle, eraser tools)
- Rework AI prompts to 4-layer format (silhouette → overlays → graphics → construction)
- Add accessory support (chains, D-rings, carabiners, grommets)
- Integrate canvas annotations into design wizard (pre-gen + post-gen markup)
- Add Puter.js TTS with neural/generative voices for podcast page
- Add 12 new 2025-2026 trend-aligned products (gorpcore, parachute, earth tones)
- Fix: design page blank step on generation failure (added retry UI)
- Fix: Puter audio not cancelled on segment click
- Fix: video page declaration order causing build error
- Fix: record page stale closure in recognition.onend
- Fix: techpack page localStorage read on every render
- Add outfit isolation rules and accessories filter to brand page
- Add CLI args (--id, --force) to VASTE generation script

Co-Authored-By: Claude Opus 4.6 <noreply@anthropic.com>
</commit_message>
<xml_diff>
--- a/CDL_Study_Tool_Showcase.pptx
+++ b/CDL_Study_Tool_Showcase.pptx
@@ -4,6 +4,9 @@
   <p:sldMasterIdLst>
     <p:sldMasterId id="2147483648" r:id="rId1"/>
   </p:sldMasterIdLst>
+  <p:notesMasterIdLst>
+    <p:notesMasterId r:id="rId12"/>
+  </p:notesMasterIdLst>
   <p:sldIdLst>
     <p:sldId id="256" r:id="rId2"/>
     <p:sldId id="257" r:id="rId3"/>
@@ -16,9 +19,6 @@
     <p:sldId id="264" r:id="rId10"/>
     <p:sldId id="265" r:id="rId11"/>
   </p:sldIdLst>
-  <p:notesMasterIdLst>
-    <p:notesMasterId r:id="rId12"/>
-  </p:notesMasterIdLst>
   <p:sldSz cx="12192000" cy="6858000"/>
   <p:notesSz cx="6858000" cy="12192000"/>
   <p:defaultTextStyle>
@@ -113,6 +113,11 @@
       </a:defRPr>
     </a:lvl9pPr>
   </p:defaultTextStyle>
+  <p:extLst>
+    <p:ext uri="{EFAFB233-063F-42B5-8137-9DF3F51BA10A}">
+      <p15:sldGuideLst xmlns:p15="http://schemas.microsoft.com/office/powerpoint/2012/main"/>
+    </p:ext>
+  </p:extLst>
 </p:presentation>
 </file>
 
@@ -138,234 +143,10 @@
           <a:chExt cx="0" cy="0"/>
         </a:xfrm>
       </p:grpSpPr>
-      <p:sp>
-        <p:nvSpPr>
-          <p:cNvPr id="2" name="Header Placeholder 1"/>
-          <p:cNvSpPr>
-            <a:spLocks noGrp="1"/>
-          </p:cNvSpPr>
-          <p:nvPr>
-            <p:ph type="hdr" sz="quarter"/>
-          </p:nvPr>
-        </p:nvSpPr>
-        <p:spPr>
-          <a:xfrm>
-            <a:off x="0" y="0"/>
-            <a:ext cx="2971800" cy="458788"/>
-          </a:xfrm>
-          <a:prstGeom prst="rect">
-            <a:avLst/>
-          </a:prstGeom>
-        </p:spPr>
-        <p:txBody>
-          <a:bodyPr vert="horz" lIns="91440" tIns="45720" rIns="91440" bIns="45720" rtlCol="0"/>
-          <a:lstStyle>
-            <a:lvl1pPr algn="l">
-              <a:defRPr sz="1200"/>
-            </a:lvl1pPr>
-          </a:lstStyle>
-          <a:p>
-            <a:endParaRPr lang="en-US"/>
-          </a:p>
-        </p:txBody>
-      </p:sp>
-      <p:sp>
-        <p:nvSpPr>
-          <p:cNvPr id="3" name="Date Placeholder 2"/>
-          <p:cNvSpPr>
-            <a:spLocks noGrp="1"/>
-          </p:cNvSpPr>
-          <p:nvPr>
-            <p:ph type="dt" idx="1"/>
-          </p:nvPr>
-        </p:nvSpPr>
-        <p:spPr>
-          <a:xfrm>
-            <a:off x="3884613" y="0"/>
-            <a:ext cx="2971800" cy="458788"/>
-          </a:xfrm>
-          <a:prstGeom prst="rect">
-            <a:avLst/>
-          </a:prstGeom>
-        </p:spPr>
-        <p:txBody>
-          <a:bodyPr vert="horz" lIns="91440" tIns="45720" rIns="91440" bIns="45720" rtlCol="0"/>
-          <a:lstStyle>
-            <a:lvl1pPr algn="r">
-              <a:defRPr sz="1200"/>
-            </a:lvl1pPr>
-          </a:lstStyle>
-          <a:p>
-            <a:fld id="{5282F153-3F37-0F45-9E97-73ACFA13230C}" type="datetimeFigureOut">
-              <a:rPr lang="en-US"/>
-              <a:t>7/23/19</a:t>
-            </a:fld>
-            <a:endParaRPr lang="en-US"/>
-          </a:p>
-        </p:txBody>
-      </p:sp>
-      <p:sp>
-        <p:nvSpPr>
-          <p:cNvPr id="4" name="Slide Image Placeholder 3"/>
-          <p:cNvSpPr>
-            <a:spLocks noGrp="1" noRot="1" noChangeAspect="1"/>
-          </p:cNvSpPr>
-          <p:nvPr>
-            <p:ph type="sldImg" idx="2"/>
-          </p:nvPr>
-        </p:nvSpPr>
-        <p:spPr>
-          <a:xfrm>
-            <a:off x="685800" y="1143000"/>
-            <a:ext cx="5486400" cy="3086100"/>
-          </a:xfrm>
-          <a:prstGeom prst="rect">
-            <a:avLst/>
-          </a:prstGeom>
-          <a:noFill/>
-          <a:ln w="12700">
-            <a:solidFill>
-              <a:prstClr val="black"/>
-            </a:solidFill>
-          </a:ln>
-        </p:spPr>
-        <p:txBody>
-          <a:bodyPr vert="horz" lIns="91440" tIns="45720" rIns="91440" bIns="45720" rtlCol="0" anchor="ctr"/>
-          <a:lstStyle/>
-          <a:p>
-            <a:endParaRPr lang="en-US"/>
-          </a:p>
-        </p:txBody>
-      </p:sp>
-      <p:sp>
-        <p:nvSpPr>
-          <p:cNvPr id="5" name="Notes Placeholder 4"/>
-          <p:cNvSpPr>
-            <a:spLocks noGrp="1"/>
-          </p:cNvSpPr>
-          <p:nvPr>
-            <p:ph type="body" sz="quarter" idx="3"/>
-          </p:nvPr>
-        </p:nvSpPr>
-        <p:spPr>
-          <a:xfrm>
-            <a:off x="685800" y="4400550"/>
-            <a:ext cx="5486400" cy="3600450"/>
-          </a:xfrm>
-          <a:prstGeom prst="rect">
-            <a:avLst/>
-          </a:prstGeom>
-        </p:spPr>
-        <p:txBody>
-          <a:bodyPr vert="horz" lIns="91440" tIns="45720" rIns="91440" bIns="45720" rtlCol="0"/>
-          <a:lstStyle/>
-          <a:p>
-            <a:pPr lvl="0"/>
-            <a:r>
-              <a:rPr lang="en-US"/>
-              <a:t>Click to edit Master text styles</a:t>
-            </a:r>
-          </a:p>
-          <a:p>
-            <a:pPr lvl="1"/>
-            <a:r>
-              <a:rPr lang="en-US"/>
-              <a:t>Second level</a:t>
-            </a:r>
-          </a:p>
-          <a:p>
-            <a:pPr lvl="2"/>
-            <a:r>
-              <a:rPr lang="en-US"/>
-              <a:t>Third level</a:t>
-            </a:r>
-          </a:p>
-          <a:p>
-            <a:pPr lvl="3"/>
-            <a:r>
-              <a:rPr lang="en-US"/>
-              <a:t>Fourth level</a:t>
-            </a:r>
-          </a:p>
-          <a:p>
-            <a:pPr lvl="4"/>
-            <a:r>
-              <a:rPr lang="en-US"/>
-              <a:t>Fifth level</a:t>
-            </a:r>
-          </a:p>
-        </p:txBody>
-      </p:sp>
-      <p:sp>
-        <p:nvSpPr>
-          <p:cNvPr id="6" name="Footer Placeholder 5"/>
-          <p:cNvSpPr>
-            <a:spLocks noGrp="1"/>
-          </p:cNvSpPr>
-          <p:nvPr>
-            <p:ph type="ftr" sz="quarter" idx="4"/>
-          </p:nvPr>
-        </p:nvSpPr>
-        <p:spPr>
-          <a:xfrm>
-            <a:off x="0" y="8685213"/>
-            <a:ext cx="2971800" cy="458787"/>
-          </a:xfrm>
-          <a:prstGeom prst="rect">
-            <a:avLst/>
-          </a:prstGeom>
-        </p:spPr>
-        <p:txBody>
-          <a:bodyPr vert="horz" lIns="91440" tIns="45720" rIns="91440" bIns="45720" rtlCol="0" anchor="b"/>
-          <a:lstStyle>
-            <a:lvl1pPr algn="l">
-              <a:defRPr sz="1200"/>
-            </a:lvl1pPr>
-          </a:lstStyle>
-          <a:p>
-            <a:endParaRPr lang="en-US"/>
-          </a:p>
-        </p:txBody>
-      </p:sp>
-      <p:sp>
-        <p:nvSpPr>
-          <p:cNvPr id="7" name="Slide Number Placeholder 6"/>
-          <p:cNvSpPr>
-            <a:spLocks noGrp="1"/>
-          </p:cNvSpPr>
-          <p:nvPr>
-            <p:ph type="sldNum" sz="quarter" idx="5"/>
-          </p:nvPr>
-        </p:nvSpPr>
-        <p:spPr>
-          <a:xfrm>
-            <a:off x="3884613" y="8685213"/>
-            <a:ext cx="2971800" cy="458787"/>
-          </a:xfrm>
-          <a:prstGeom prst="rect">
-            <a:avLst/>
-          </a:prstGeom>
-        </p:spPr>
-        <p:txBody>
-          <a:bodyPr vert="horz" lIns="91440" tIns="45720" rIns="91440" bIns="45720" rtlCol="0" anchor="b"/>
-          <a:lstStyle>
-            <a:lvl1pPr algn="r">
-              <a:defRPr sz="1200"/>
-            </a:lvl1pPr>
-          </a:lstStyle>
-          <a:p>
-            <a:fld id="{CE5E9CC1-C706-0F49-92D6-E571CC5EEA8F}" type="slidenum">
-              <a:rPr lang="en-US"/>
-              <a:t>‹#›</a:t>
-            </a:fld>
-            <a:endParaRPr lang="en-US"/>
-          </a:p>
-        </p:txBody>
-      </p:sp>
     </p:spTree>
     <p:extLst>
       <p:ext uri="{BB962C8B-B14F-4D97-AF65-F5344CB8AC3E}">
-        <p14:creationId xmlns:p14="http://schemas.microsoft.com/office/powerpoint/2010/main" val="1024086991"/>
+        <p14:creationId xmlns:p14="http://schemas.microsoft.com/office/powerpoint/2010/main" val="155734881"/>
       </p:ext>
     </p:extLst>
   </p:cSld>
@@ -513,7 +294,6 @@
               <a:rPr lang="en-US" dirty="0"/>
               <a:t>Title slide introducing CDL Study Tool</a:t>
             </a:r>
-            <a:endParaRPr lang="en-US" dirty="0"/>
           </a:p>
         </p:txBody>
       </p:sp>
@@ -601,7 +381,6 @@
               <a:rPr lang="en-US" dirty="0"/>
               <a:t>Closing slide with CTA and Snapchat</a:t>
             </a:r>
-            <a:endParaRPr lang="en-US" dirty="0"/>
           </a:p>
         </p:txBody>
       </p:sp>
@@ -689,7 +468,6 @@
               <a:rPr lang="en-US" dirty="0"/>
               <a:t>Highlight the pain points students face</a:t>
             </a:r>
-            <a:endParaRPr lang="en-US" dirty="0"/>
           </a:p>
         </p:txBody>
       </p:sp>
@@ -777,7 +555,6 @@
               <a:rPr lang="en-US" dirty="0"/>
               <a:t>3-step solution overview: Record, Study, Create</a:t>
             </a:r>
-            <a:endParaRPr lang="en-US" dirty="0"/>
           </a:p>
         </p:txBody>
       </p:sp>
@@ -865,7 +642,6 @@
               <a:rPr lang="en-US" dirty="0"/>
               <a:t>All 7 AI providers including the free built-in option</a:t>
             </a:r>
-            <a:endParaRPr lang="en-US" dirty="0"/>
           </a:p>
         </p:txBody>
       </p:sp>
@@ -953,7 +729,6 @@
               <a:rPr lang="en-US" dirty="0"/>
               <a:t>Highlight the pro presentation features with morph and 21 layouts</a:t>
             </a:r>
-            <a:endParaRPr lang="en-US" dirty="0"/>
           </a:p>
         </p:txBody>
       </p:sp>
@@ -1041,7 +816,6 @@
               <a:rPr lang="en-US" dirty="0"/>
               <a:t>4-step process flow showing how CDL Study Tool works</a:t>
             </a:r>
-            <a:endParaRPr lang="en-US" dirty="0"/>
           </a:p>
         </p:txBody>
       </p:sp>
@@ -1129,7 +903,6 @@
               <a:rPr lang="en-US" dirty="0"/>
               <a:t>Key stats about the platform</a:t>
             </a:r>
-            <a:endParaRPr lang="en-US" dirty="0"/>
           </a:p>
         </p:txBody>
       </p:sp>
@@ -1217,7 +990,6 @@
               <a:rPr lang="en-US" dirty="0"/>
               <a:t>Side-by-side comparison showing the value proposition</a:t>
             </a:r>
-            <a:endParaRPr lang="en-US" dirty="0"/>
           </a:p>
         </p:txBody>
       </p:sp>
@@ -1305,7 +1077,6 @@
               <a:rPr lang="en-US" dirty="0"/>
               <a:t>Pricing tiers with the beta notice</a:t>
             </a:r>
-            <a:endParaRPr lang="en-US" dirty="0"/>
           </a:p>
         </p:txBody>
       </p:sp>
@@ -1378,6 +1149,11 @@
 <file path=ppt/slideMasters/slideMaster1.xml><?xml version="1.0" encoding="utf-8"?>
 <p:sldMaster xmlns:a="http://schemas.openxmlformats.org/drawingml/2006/main" xmlns:r="http://schemas.openxmlformats.org/officeDocument/2006/relationships" xmlns:p="http://schemas.openxmlformats.org/presentationml/2006/main">
   <p:cSld>
+    <p:bg>
+      <p:bgRef idx="1001">
+        <a:schemeClr val="bg1"/>
+      </p:bgRef>
+    </p:bg>
     <p:spTree>
       <p:nvGrpSpPr>
         <p:cNvPr id="1" name=""/>
@@ -1660,6 +1436,7 @@
         <a:solidFill>
           <a:srgbClr val="0F172A"/>
         </a:solidFill>
+        <a:effectLst/>
       </p:bgPr>
     </p:bg>
     <p:spTree>
@@ -1697,6 +1474,13 @@
           </a:solidFill>
           <a:ln/>
         </p:spPr>
+        <p:txBody>
+          <a:bodyPr/>
+          <a:lstStyle/>
+          <a:p>
+            <a:endParaRPr lang="en-CH"/>
+          </a:p>
+        </p:txBody>
       </p:sp>
       <p:sp>
         <p:nvSpPr>
@@ -1719,6 +1503,13 @@
           </a:solidFill>
           <a:ln/>
         </p:spPr>
+        <p:txBody>
+          <a:bodyPr/>
+          <a:lstStyle/>
+          <a:p>
+            <a:endParaRPr lang="en-CH"/>
+          </a:p>
+        </p:txBody>
       </p:sp>
       <p:sp>
         <p:nvSpPr>
@@ -1741,6 +1532,13 @@
           </a:solidFill>
           <a:ln/>
         </p:spPr>
+        <p:txBody>
+          <a:bodyPr/>
+          <a:lstStyle/>
+          <a:p>
+            <a:endParaRPr lang="en-CH"/>
+          </a:p>
+        </p:txBody>
       </p:sp>
       <p:sp>
         <p:nvSpPr>
@@ -1763,7 +1561,7 @@
           <a:bodyPr wrap="square" rtlCol="0" anchor="ctr"/>
           <a:lstStyle/>
           <a:p>
-            <a:pPr algn="ctr" indent="0" marL="0">
+            <a:pPr marL="0" indent="0" algn="ctr">
               <a:buNone/>
             </a:pPr>
             <a:r>
@@ -1802,7 +1600,7 @@
           <a:bodyPr wrap="square" rtlCol="0" anchor="ctr"/>
           <a:lstStyle/>
           <a:p>
-            <a:pPr algn="ctr" indent="0" marL="0">
+            <a:pPr marL="0" indent="0" algn="ctr">
               <a:buNone/>
             </a:pPr>
             <a:r>
@@ -1841,7 +1639,7 @@
           <a:bodyPr wrap="square" rtlCol="0" anchor="ctr"/>
           <a:lstStyle/>
           <a:p>
-            <a:pPr algn="ctr" indent="0" marL="0">
+            <a:pPr marL="0" indent="0" algn="ctr">
               <a:buNone/>
             </a:pPr>
             <a:r>
@@ -1866,6 +1664,18 @@
   <p:clrMapOvr>
     <a:masterClrMapping/>
   </p:clrMapOvr>
+  <mc:AlternateContent xmlns:mc="http://schemas.openxmlformats.org/markup-compatibility/2006">
+    <mc:Choice xmlns:p159="http://schemas.microsoft.com/office/powerpoint/2015/09/main" Requires="p159">
+      <p:transition xmlns:p14="http://schemas.microsoft.com/office/powerpoint/2010/main" spd="slow" p14:dur="2000">
+        <p159:morph option="byObject"/>
+      </p:transition>
+    </mc:Choice>
+    <mc:Fallback>
+      <p:transition spd="slow">
+        <p:fade/>
+      </p:transition>
+    </mc:Fallback>
+  </mc:AlternateContent>
 </p:sld>
 </file>
 
@@ -1877,6 +1687,7 @@
         <a:solidFill>
           <a:srgbClr val="6366F1"/>
         </a:solidFill>
+        <a:effectLst/>
       </p:bgPr>
     </p:bg>
     <p:spTree>
@@ -1914,6 +1725,13 @@
           </a:solidFill>
           <a:ln/>
         </p:spPr>
+        <p:txBody>
+          <a:bodyPr/>
+          <a:lstStyle/>
+          <a:p>
+            <a:endParaRPr lang="en-CH"/>
+          </a:p>
+        </p:txBody>
       </p:sp>
       <p:sp>
         <p:nvSpPr>
@@ -1936,6 +1754,13 @@
           </a:solidFill>
           <a:ln/>
         </p:spPr>
+        <p:txBody>
+          <a:bodyPr/>
+          <a:lstStyle/>
+          <a:p>
+            <a:endParaRPr lang="en-CH"/>
+          </a:p>
+        </p:txBody>
       </p:sp>
       <p:sp>
         <p:nvSpPr>
@@ -1958,6 +1783,13 @@
           </a:solidFill>
           <a:ln/>
         </p:spPr>
+        <p:txBody>
+          <a:bodyPr/>
+          <a:lstStyle/>
+          <a:p>
+            <a:endParaRPr lang="en-CH"/>
+          </a:p>
+        </p:txBody>
       </p:sp>
       <p:sp>
         <p:nvSpPr>
@@ -1980,7 +1812,7 @@
           <a:bodyPr wrap="square" rtlCol="0" anchor="ctr"/>
           <a:lstStyle/>
           <a:p>
-            <a:pPr algn="ctr" indent="0" marL="0">
+            <a:pPr marL="0" indent="0" algn="ctr">
               <a:buNone/>
             </a:pPr>
             <a:r>
@@ -2019,7 +1851,7 @@
           <a:bodyPr wrap="square" rtlCol="0" anchor="ctr"/>
           <a:lstStyle/>
           <a:p>
-            <a:pPr algn="ctr" indent="0" marL="0">
+            <a:pPr marL="0" indent="0" algn="ctr">
               <a:buNone/>
             </a:pPr>
             <a:r>
@@ -2062,6 +1894,13 @@
           </a:solidFill>
           <a:ln/>
         </p:spPr>
+        <p:txBody>
+          <a:bodyPr/>
+          <a:lstStyle/>
+          <a:p>
+            <a:endParaRPr lang="en-CH"/>
+          </a:p>
+        </p:txBody>
       </p:sp>
       <p:sp>
         <p:nvSpPr>
@@ -2091,6 +1930,13 @@
             <a:prstDash val="solid"/>
           </a:ln>
         </p:spPr>
+        <p:txBody>
+          <a:bodyPr/>
+          <a:lstStyle/>
+          <a:p>
+            <a:endParaRPr lang="en-CH"/>
+          </a:p>
+        </p:txBody>
       </p:sp>
       <p:sp>
         <p:nvSpPr>
@@ -2113,7 +1959,7 @@
           <a:bodyPr wrap="square" rtlCol="0" anchor="ctr"/>
           <a:lstStyle/>
           <a:p>
-            <a:pPr algn="ctr" indent="0" marL="0">
+            <a:pPr marL="0" indent="0" algn="ctr">
               <a:buNone/>
             </a:pPr>
             <a:r>
@@ -2152,7 +1998,7 @@
           <a:bodyPr wrap="square" rtlCol="0" anchor="ctr"/>
           <a:lstStyle/>
           <a:p>
-            <a:pPr algn="ctr" indent="0" marL="0">
+            <a:pPr marL="0" indent="0" algn="ctr">
               <a:buNone/>
             </a:pPr>
             <a:r>
@@ -2177,6 +2023,18 @@
   <p:clrMapOvr>
     <a:masterClrMapping/>
   </p:clrMapOvr>
+  <mc:AlternateContent xmlns:mc="http://schemas.openxmlformats.org/markup-compatibility/2006">
+    <mc:Choice xmlns:p159="http://schemas.microsoft.com/office/powerpoint/2015/09/main" Requires="p159">
+      <p:transition xmlns:p14="http://schemas.microsoft.com/office/powerpoint/2010/main" spd="slow" p14:dur="2000">
+        <p159:morph option="byObject"/>
+      </p:transition>
+    </mc:Choice>
+    <mc:Fallback>
+      <p:transition spd="slow">
+        <p:fade/>
+      </p:transition>
+    </mc:Fallback>
+  </mc:AlternateContent>
 </p:sld>
 </file>
 
@@ -2188,6 +2046,7 @@
         <a:solidFill>
           <a:srgbClr val="0F172A"/>
         </a:solidFill>
+        <a:effectLst/>
       </p:bgPr>
     </p:bg>
     <p:spTree>
@@ -2225,6 +2084,13 @@
           </a:solidFill>
           <a:ln/>
         </p:spPr>
+        <p:txBody>
+          <a:bodyPr/>
+          <a:lstStyle/>
+          <a:p>
+            <a:endParaRPr lang="en-CH"/>
+          </a:p>
+        </p:txBody>
       </p:sp>
       <p:sp>
         <p:nvSpPr>
@@ -2247,6 +2113,13 @@
           </a:solidFill>
           <a:ln/>
         </p:spPr>
+        <p:txBody>
+          <a:bodyPr/>
+          <a:lstStyle/>
+          <a:p>
+            <a:endParaRPr lang="en-CH"/>
+          </a:p>
+        </p:txBody>
       </p:sp>
       <p:sp>
         <p:nvSpPr>
@@ -2269,11 +2142,11 @@
           <a:bodyPr wrap="square" rtlCol="0" anchor="ctr"/>
           <a:lstStyle/>
           <a:p>
-            <a:pPr algn="ctr" indent="0" marL="0">
-              <a:buNone/>
-            </a:pPr>
-            <a:r>
-              <a:rPr lang="en-US" sz="1200" b="1" spc="400" kern="0" dirty="0">
+            <a:pPr marL="0" indent="0" algn="ctr">
+              <a:buNone/>
+            </a:pPr>
+            <a:r>
+              <a:rPr lang="en-US" sz="1200" b="1" kern="0" spc="400" dirty="0">
                 <a:solidFill>
                   <a:srgbClr val="A78BFA"/>
                 </a:solidFill>
@@ -2310,6 +2183,13 @@
           </a:solidFill>
           <a:ln/>
         </p:spPr>
+        <p:txBody>
+          <a:bodyPr/>
+          <a:lstStyle/>
+          <a:p>
+            <a:endParaRPr lang="en-CH"/>
+          </a:p>
+        </p:txBody>
       </p:sp>
       <p:sp>
         <p:nvSpPr>
@@ -2339,6 +2219,13 @@
             <a:prstDash val="solid"/>
           </a:ln>
         </p:spPr>
+        <p:txBody>
+          <a:bodyPr/>
+          <a:lstStyle/>
+          <a:p>
+            <a:endParaRPr lang="en-CH"/>
+          </a:p>
+        </p:txBody>
       </p:sp>
       <p:sp>
         <p:nvSpPr>
@@ -2361,7 +2248,7 @@
           <a:bodyPr wrap="square" rtlCol="0" anchor="ctr"/>
           <a:lstStyle/>
           <a:p>
-            <a:pPr algn="ctr" indent="0" marL="0">
+            <a:pPr marL="0" indent="0" algn="ctr">
               <a:buNone/>
             </a:pPr>
             <a:r>
@@ -2400,7 +2287,7 @@
           <a:bodyPr wrap="square" rtlCol="0" anchor="ctr"/>
           <a:lstStyle/>
           <a:p>
-            <a:pPr algn="ctr" indent="0" marL="0">
+            <a:pPr marL="0" indent="0" algn="ctr">
               <a:lnSpc>
                 <a:spcPct val="140000"/>
               </a:lnSpc>
@@ -2422,7 +2309,7 @@
             <a:endParaRPr lang="en-US" sz="1600" dirty="0"/>
           </a:p>
           <a:p>
-            <a:pPr algn="ctr" indent="0" marL="0">
+            <a:pPr marL="0" indent="0" algn="ctr">
               <a:lnSpc>
                 <a:spcPct val="140000"/>
               </a:lnSpc>
@@ -2450,6 +2337,18 @@
   <p:clrMapOvr>
     <a:masterClrMapping/>
   </p:clrMapOvr>
+  <mc:AlternateContent xmlns:mc="http://schemas.openxmlformats.org/markup-compatibility/2006">
+    <mc:Choice xmlns:p159="http://schemas.microsoft.com/office/powerpoint/2015/09/main" Requires="p159">
+      <p:transition xmlns:p14="http://schemas.microsoft.com/office/powerpoint/2010/main" spd="slow" p14:dur="2000">
+        <p159:morph option="byObject"/>
+      </p:transition>
+    </mc:Choice>
+    <mc:Fallback>
+      <p:transition spd="slow">
+        <p:fade/>
+      </p:transition>
+    </mc:Fallback>
+  </mc:AlternateContent>
 </p:sld>
 </file>
 
@@ -2461,6 +2360,7 @@
         <a:solidFill>
           <a:srgbClr val="F8FAFC"/>
         </a:solidFill>
+        <a:effectLst/>
       </p:bgPr>
     </p:bg>
     <p:spTree>
@@ -2498,7 +2398,7 @@
           <a:bodyPr wrap="square" rtlCol="0" anchor="ctr"/>
           <a:lstStyle/>
           <a:p>
-            <a:pPr algn="ctr" indent="0" marL="0">
+            <a:pPr marL="0" indent="0" algn="ctr">
               <a:buNone/>
             </a:pPr>
             <a:r>
@@ -2539,6 +2439,13 @@
           </a:solidFill>
           <a:ln/>
         </p:spPr>
+        <p:txBody>
+          <a:bodyPr/>
+          <a:lstStyle/>
+          <a:p>
+            <a:endParaRPr lang="en-CH"/>
+          </a:p>
+        </p:txBody>
       </p:sp>
       <p:sp>
         <p:nvSpPr>
@@ -2568,6 +2475,13 @@
             <a:prstDash val="solid"/>
           </a:ln>
         </p:spPr>
+        <p:txBody>
+          <a:bodyPr/>
+          <a:lstStyle/>
+          <a:p>
+            <a:endParaRPr lang="en-CH"/>
+          </a:p>
+        </p:txBody>
       </p:sp>
       <p:sp>
         <p:nvSpPr>
@@ -2588,6 +2502,13 @@
           </a:solidFill>
           <a:ln/>
         </p:spPr>
+        <p:txBody>
+          <a:bodyPr/>
+          <a:lstStyle/>
+          <a:p>
+            <a:endParaRPr lang="en-CH"/>
+          </a:p>
+        </p:txBody>
       </p:sp>
       <p:sp>
         <p:nvSpPr>
@@ -2610,7 +2531,7 @@
           <a:bodyPr wrap="square" rtlCol="0" anchor="ctr"/>
           <a:lstStyle/>
           <a:p>
-            <a:pPr algn="ctr" indent="0" marL="0">
+            <a:pPr marL="0" indent="0" algn="ctr">
               <a:buNone/>
             </a:pPr>
             <a:r>
@@ -2646,7 +2567,7 @@
           <a:bodyPr wrap="square" rtlCol="0" anchor="ctr"/>
           <a:lstStyle/>
           <a:p>
-            <a:pPr algn="ctr" indent="0" marL="0">
+            <a:pPr marL="0" indent="0" algn="ctr">
               <a:buNone/>
             </a:pPr>
             <a:r>
@@ -2685,7 +2606,7 @@
           <a:bodyPr wrap="square" rtlCol="0" anchor="ctr"/>
           <a:lstStyle/>
           <a:p>
-            <a:pPr algn="ctr" indent="0" marL="0">
+            <a:pPr marL="0" indent="0" algn="ctr">
               <a:lnSpc>
                 <a:spcPct val="130000"/>
               </a:lnSpc>
@@ -2729,6 +2650,13 @@
           </a:solidFill>
           <a:ln/>
         </p:spPr>
+        <p:txBody>
+          <a:bodyPr/>
+          <a:lstStyle/>
+          <a:p>
+            <a:endParaRPr lang="en-CH"/>
+          </a:p>
+        </p:txBody>
       </p:sp>
       <p:sp>
         <p:nvSpPr>
@@ -2758,6 +2686,13 @@
             <a:prstDash val="solid"/>
           </a:ln>
         </p:spPr>
+        <p:txBody>
+          <a:bodyPr/>
+          <a:lstStyle/>
+          <a:p>
+            <a:endParaRPr lang="en-CH"/>
+          </a:p>
+        </p:txBody>
       </p:sp>
       <p:sp>
         <p:nvSpPr>
@@ -2778,6 +2713,13 @@
           </a:solidFill>
           <a:ln/>
         </p:spPr>
+        <p:txBody>
+          <a:bodyPr/>
+          <a:lstStyle/>
+          <a:p>
+            <a:endParaRPr lang="en-CH"/>
+          </a:p>
+        </p:txBody>
       </p:sp>
       <p:sp>
         <p:nvSpPr>
@@ -2800,7 +2742,7 @@
           <a:bodyPr wrap="square" rtlCol="0" anchor="ctr"/>
           <a:lstStyle/>
           <a:p>
-            <a:pPr algn="ctr" indent="0" marL="0">
+            <a:pPr marL="0" indent="0" algn="ctr">
               <a:buNone/>
             </a:pPr>
             <a:r>
@@ -2836,7 +2778,7 @@
           <a:bodyPr wrap="square" rtlCol="0" anchor="ctr"/>
           <a:lstStyle/>
           <a:p>
-            <a:pPr algn="ctr" indent="0" marL="0">
+            <a:pPr marL="0" indent="0" algn="ctr">
               <a:buNone/>
             </a:pPr>
             <a:r>
@@ -2875,7 +2817,7 @@
           <a:bodyPr wrap="square" rtlCol="0" anchor="ctr"/>
           <a:lstStyle/>
           <a:p>
-            <a:pPr algn="ctr" indent="0" marL="0">
+            <a:pPr marL="0" indent="0" algn="ctr">
               <a:lnSpc>
                 <a:spcPct val="130000"/>
               </a:lnSpc>
@@ -2919,6 +2861,13 @@
           </a:solidFill>
           <a:ln/>
         </p:spPr>
+        <p:txBody>
+          <a:bodyPr/>
+          <a:lstStyle/>
+          <a:p>
+            <a:endParaRPr lang="en-CH"/>
+          </a:p>
+        </p:txBody>
       </p:sp>
       <p:sp>
         <p:nvSpPr>
@@ -2948,6 +2897,13 @@
             <a:prstDash val="solid"/>
           </a:ln>
         </p:spPr>
+        <p:txBody>
+          <a:bodyPr/>
+          <a:lstStyle/>
+          <a:p>
+            <a:endParaRPr lang="en-CH"/>
+          </a:p>
+        </p:txBody>
       </p:sp>
       <p:sp>
         <p:nvSpPr>
@@ -2968,6 +2924,13 @@
           </a:solidFill>
           <a:ln/>
         </p:spPr>
+        <p:txBody>
+          <a:bodyPr/>
+          <a:lstStyle/>
+          <a:p>
+            <a:endParaRPr lang="en-CH"/>
+          </a:p>
+        </p:txBody>
       </p:sp>
       <p:sp>
         <p:nvSpPr>
@@ -2990,7 +2953,7 @@
           <a:bodyPr wrap="square" rtlCol="0" anchor="ctr"/>
           <a:lstStyle/>
           <a:p>
-            <a:pPr algn="ctr" indent="0" marL="0">
+            <a:pPr marL="0" indent="0" algn="ctr">
               <a:buNone/>
             </a:pPr>
             <a:r>
@@ -3026,7 +2989,7 @@
           <a:bodyPr wrap="square" rtlCol="0" anchor="ctr"/>
           <a:lstStyle/>
           <a:p>
-            <a:pPr algn="ctr" indent="0" marL="0">
+            <a:pPr marL="0" indent="0" algn="ctr">
               <a:buNone/>
             </a:pPr>
             <a:r>
@@ -3065,7 +3028,7 @@
           <a:bodyPr wrap="square" rtlCol="0" anchor="ctr"/>
           <a:lstStyle/>
           <a:p>
-            <a:pPr algn="ctr" indent="0" marL="0">
+            <a:pPr marL="0" indent="0" algn="ctr">
               <a:lnSpc>
                 <a:spcPct val="130000"/>
               </a:lnSpc>
@@ -3091,6 +3054,18 @@
   <p:clrMapOvr>
     <a:masterClrMapping/>
   </p:clrMapOvr>
+  <mc:AlternateContent xmlns:mc="http://schemas.openxmlformats.org/markup-compatibility/2006">
+    <mc:Choice xmlns:p159="http://schemas.microsoft.com/office/powerpoint/2015/09/main" Requires="p159">
+      <p:transition xmlns:p14="http://schemas.microsoft.com/office/powerpoint/2010/main" spd="slow" p14:dur="2000">
+        <p159:morph option="byObject"/>
+      </p:transition>
+    </mc:Choice>
+    <mc:Fallback>
+      <p:transition spd="slow">
+        <p:fade/>
+      </p:transition>
+    </mc:Fallback>
+  </mc:AlternateContent>
 </p:sld>
 </file>
 
@@ -3102,6 +3077,7 @@
         <a:solidFill>
           <a:srgbClr val="0F172A"/>
         </a:solidFill>
+        <a:effectLst/>
       </p:bgPr>
     </p:bg>
     <p:spTree>
@@ -3139,6 +3115,13 @@
           </a:solidFill>
           <a:ln/>
         </p:spPr>
+        <p:txBody>
+          <a:bodyPr/>
+          <a:lstStyle/>
+          <a:p>
+            <a:endParaRPr lang="en-CH"/>
+          </a:p>
+        </p:txBody>
       </p:sp>
       <p:sp>
         <p:nvSpPr>
@@ -3161,6 +3144,13 @@
           </a:solidFill>
           <a:ln/>
         </p:spPr>
+        <p:txBody>
+          <a:bodyPr/>
+          <a:lstStyle/>
+          <a:p>
+            <a:endParaRPr lang="en-CH"/>
+          </a:p>
+        </p:txBody>
       </p:sp>
       <p:sp>
         <p:nvSpPr>
@@ -3183,7 +3173,7 @@
           <a:bodyPr wrap="square" rtlCol="0" anchor="ctr"/>
           <a:lstStyle/>
           <a:p>
-            <a:pPr algn="ctr" indent="0" marL="0">
+            <a:pPr marL="0" indent="0" algn="ctr">
               <a:buNone/>
             </a:pPr>
             <a:r>
@@ -3224,6 +3214,13 @@
           </a:solidFill>
           <a:ln/>
         </p:spPr>
+        <p:txBody>
+          <a:bodyPr/>
+          <a:lstStyle/>
+          <a:p>
+            <a:endParaRPr lang="en-CH"/>
+          </a:p>
+        </p:txBody>
       </p:sp>
       <p:sp>
         <p:nvSpPr>
@@ -3253,6 +3250,13 @@
             <a:prstDash val="solid"/>
           </a:ln>
         </p:spPr>
+        <p:txBody>
+          <a:bodyPr/>
+          <a:lstStyle/>
+          <a:p>
+            <a:endParaRPr lang="en-CH"/>
+          </a:p>
+        </p:txBody>
       </p:sp>
       <p:sp>
         <p:nvSpPr>
@@ -3275,7 +3279,7 @@
           <a:bodyPr wrap="square" rtlCol="0" anchor="ctr"/>
           <a:lstStyle/>
           <a:p>
-            <a:pPr algn="ctr" indent="0" marL="0">
+            <a:pPr marL="0" indent="0" algn="ctr">
               <a:buNone/>
             </a:pPr>
             <a:r>
@@ -3311,7 +3315,7 @@
           <a:bodyPr wrap="square" rtlCol="0" anchor="ctr"/>
           <a:lstStyle/>
           <a:p>
-            <a:pPr algn="ctr" indent="0" marL="0">
+            <a:pPr marL="0" indent="0" algn="ctr">
               <a:buNone/>
             </a:pPr>
             <a:r>
@@ -3350,7 +3354,7 @@
           <a:bodyPr wrap="square" rtlCol="0" anchor="ctr"/>
           <a:lstStyle/>
           <a:p>
-            <a:pPr algn="ctr" indent="0" marL="0">
+            <a:pPr marL="0" indent="0" algn="ctr">
               <a:buNone/>
             </a:pPr>
             <a:r>
@@ -3391,6 +3395,13 @@
           </a:solidFill>
           <a:ln/>
         </p:spPr>
+        <p:txBody>
+          <a:bodyPr/>
+          <a:lstStyle/>
+          <a:p>
+            <a:endParaRPr lang="en-CH"/>
+          </a:p>
+        </p:txBody>
       </p:sp>
       <p:sp>
         <p:nvSpPr>
@@ -3420,6 +3431,13 @@
             <a:prstDash val="solid"/>
           </a:ln>
         </p:spPr>
+        <p:txBody>
+          <a:bodyPr/>
+          <a:lstStyle/>
+          <a:p>
+            <a:endParaRPr lang="en-CH"/>
+          </a:p>
+        </p:txBody>
       </p:sp>
       <p:sp>
         <p:nvSpPr>
@@ -3442,7 +3460,7 @@
           <a:bodyPr wrap="square" rtlCol="0" anchor="ctr"/>
           <a:lstStyle/>
           <a:p>
-            <a:pPr algn="ctr" indent="0" marL="0">
+            <a:pPr marL="0" indent="0" algn="ctr">
               <a:buNone/>
             </a:pPr>
             <a:r>
@@ -3478,7 +3496,7 @@
           <a:bodyPr wrap="square" rtlCol="0" anchor="ctr"/>
           <a:lstStyle/>
           <a:p>
-            <a:pPr algn="ctr" indent="0" marL="0">
+            <a:pPr marL="0" indent="0" algn="ctr">
               <a:buNone/>
             </a:pPr>
             <a:r>
@@ -3517,7 +3535,7 @@
           <a:bodyPr wrap="square" rtlCol="0" anchor="ctr"/>
           <a:lstStyle/>
           <a:p>
-            <a:pPr algn="ctr" indent="0" marL="0">
+            <a:pPr marL="0" indent="0" algn="ctr">
               <a:buNone/>
             </a:pPr>
             <a:r>
@@ -3558,6 +3576,13 @@
           </a:solidFill>
           <a:ln/>
         </p:spPr>
+        <p:txBody>
+          <a:bodyPr/>
+          <a:lstStyle/>
+          <a:p>
+            <a:endParaRPr lang="en-CH"/>
+          </a:p>
+        </p:txBody>
       </p:sp>
       <p:sp>
         <p:nvSpPr>
@@ -3587,6 +3612,13 @@
             <a:prstDash val="solid"/>
           </a:ln>
         </p:spPr>
+        <p:txBody>
+          <a:bodyPr/>
+          <a:lstStyle/>
+          <a:p>
+            <a:endParaRPr lang="en-CH"/>
+          </a:p>
+        </p:txBody>
       </p:sp>
       <p:sp>
         <p:nvSpPr>
@@ -3609,7 +3641,7 @@
           <a:bodyPr wrap="square" rtlCol="0" anchor="ctr"/>
           <a:lstStyle/>
           <a:p>
-            <a:pPr algn="ctr" indent="0" marL="0">
+            <a:pPr marL="0" indent="0" algn="ctr">
               <a:buNone/>
             </a:pPr>
             <a:r>
@@ -3645,7 +3677,7 @@
           <a:bodyPr wrap="square" rtlCol="0" anchor="ctr"/>
           <a:lstStyle/>
           <a:p>
-            <a:pPr algn="ctr" indent="0" marL="0">
+            <a:pPr marL="0" indent="0" algn="ctr">
               <a:buNone/>
             </a:pPr>
             <a:r>
@@ -3684,7 +3716,7 @@
           <a:bodyPr wrap="square" rtlCol="0" anchor="ctr"/>
           <a:lstStyle/>
           <a:p>
-            <a:pPr algn="ctr" indent="0" marL="0">
+            <a:pPr marL="0" indent="0" algn="ctr">
               <a:buNone/>
             </a:pPr>
             <a:r>
@@ -3725,6 +3757,13 @@
           </a:solidFill>
           <a:ln/>
         </p:spPr>
+        <p:txBody>
+          <a:bodyPr/>
+          <a:lstStyle/>
+          <a:p>
+            <a:endParaRPr lang="en-CH"/>
+          </a:p>
+        </p:txBody>
       </p:sp>
       <p:sp>
         <p:nvSpPr>
@@ -3754,6 +3793,13 @@
             <a:prstDash val="solid"/>
           </a:ln>
         </p:spPr>
+        <p:txBody>
+          <a:bodyPr/>
+          <a:lstStyle/>
+          <a:p>
+            <a:endParaRPr lang="en-CH"/>
+          </a:p>
+        </p:txBody>
       </p:sp>
       <p:sp>
         <p:nvSpPr>
@@ -3776,7 +3822,7 @@
           <a:bodyPr wrap="square" rtlCol="0" anchor="ctr"/>
           <a:lstStyle/>
           <a:p>
-            <a:pPr algn="ctr" indent="0" marL="0">
+            <a:pPr marL="0" indent="0" algn="ctr">
               <a:buNone/>
             </a:pPr>
             <a:r>
@@ -3812,7 +3858,7 @@
           <a:bodyPr wrap="square" rtlCol="0" anchor="ctr"/>
           <a:lstStyle/>
           <a:p>
-            <a:pPr algn="ctr" indent="0" marL="0">
+            <a:pPr marL="0" indent="0" algn="ctr">
               <a:buNone/>
             </a:pPr>
             <a:r>
@@ -3851,7 +3897,7 @@
           <a:bodyPr wrap="square" rtlCol="0" anchor="ctr"/>
           <a:lstStyle/>
           <a:p>
-            <a:pPr algn="ctr" indent="0" marL="0">
+            <a:pPr marL="0" indent="0" algn="ctr">
               <a:buNone/>
             </a:pPr>
             <a:r>
@@ -3892,6 +3938,13 @@
           </a:solidFill>
           <a:ln/>
         </p:spPr>
+        <p:txBody>
+          <a:bodyPr/>
+          <a:lstStyle/>
+          <a:p>
+            <a:endParaRPr lang="en-CH"/>
+          </a:p>
+        </p:txBody>
       </p:sp>
       <p:sp>
         <p:nvSpPr>
@@ -3921,6 +3974,13 @@
             <a:prstDash val="solid"/>
           </a:ln>
         </p:spPr>
+        <p:txBody>
+          <a:bodyPr/>
+          <a:lstStyle/>
+          <a:p>
+            <a:endParaRPr lang="en-CH"/>
+          </a:p>
+        </p:txBody>
       </p:sp>
       <p:sp>
         <p:nvSpPr>
@@ -3943,7 +4003,7 @@
           <a:bodyPr wrap="square" rtlCol="0" anchor="ctr"/>
           <a:lstStyle/>
           <a:p>
-            <a:pPr algn="ctr" indent="0" marL="0">
+            <a:pPr marL="0" indent="0" algn="ctr">
               <a:buNone/>
             </a:pPr>
             <a:r>
@@ -3979,7 +4039,7 @@
           <a:bodyPr wrap="square" rtlCol="0" anchor="ctr"/>
           <a:lstStyle/>
           <a:p>
-            <a:pPr algn="ctr" indent="0" marL="0">
+            <a:pPr marL="0" indent="0" algn="ctr">
               <a:buNone/>
             </a:pPr>
             <a:r>
@@ -4018,7 +4078,7 @@
           <a:bodyPr wrap="square" rtlCol="0" anchor="ctr"/>
           <a:lstStyle/>
           <a:p>
-            <a:pPr algn="ctr" indent="0" marL="0">
+            <a:pPr marL="0" indent="0" algn="ctr">
               <a:buNone/>
             </a:pPr>
             <a:r>
@@ -4059,6 +4119,13 @@
           </a:solidFill>
           <a:ln/>
         </p:spPr>
+        <p:txBody>
+          <a:bodyPr/>
+          <a:lstStyle/>
+          <a:p>
+            <a:endParaRPr lang="en-CH"/>
+          </a:p>
+        </p:txBody>
       </p:sp>
       <p:sp>
         <p:nvSpPr>
@@ -4088,6 +4155,13 @@
             <a:prstDash val="solid"/>
           </a:ln>
         </p:spPr>
+        <p:txBody>
+          <a:bodyPr/>
+          <a:lstStyle/>
+          <a:p>
+            <a:endParaRPr lang="en-CH"/>
+          </a:p>
+        </p:txBody>
       </p:sp>
       <p:sp>
         <p:nvSpPr>
@@ -4110,7 +4184,7 @@
           <a:bodyPr wrap="square" rtlCol="0" anchor="ctr"/>
           <a:lstStyle/>
           <a:p>
-            <a:pPr algn="ctr" indent="0" marL="0">
+            <a:pPr marL="0" indent="0" algn="ctr">
               <a:buNone/>
             </a:pPr>
             <a:r>
@@ -4146,7 +4220,7 @@
           <a:bodyPr wrap="square" rtlCol="0" anchor="ctr"/>
           <a:lstStyle/>
           <a:p>
-            <a:pPr algn="ctr" indent="0" marL="0">
+            <a:pPr marL="0" indent="0" algn="ctr">
               <a:buNone/>
             </a:pPr>
             <a:r>
@@ -4185,7 +4259,7 @@
           <a:bodyPr wrap="square" rtlCol="0" anchor="ctr"/>
           <a:lstStyle/>
           <a:p>
-            <a:pPr algn="ctr" indent="0" marL="0">
+            <a:pPr marL="0" indent="0" algn="ctr">
               <a:buNone/>
             </a:pPr>
             <a:r>
@@ -4208,6 +4282,18 @@
   <p:clrMapOvr>
     <a:masterClrMapping/>
   </p:clrMapOvr>
+  <mc:AlternateContent xmlns:mc="http://schemas.openxmlformats.org/markup-compatibility/2006">
+    <mc:Choice xmlns:p159="http://schemas.microsoft.com/office/powerpoint/2015/09/main" Requires="p159">
+      <p:transition xmlns:p14="http://schemas.microsoft.com/office/powerpoint/2010/main" spd="slow" p14:dur="2000">
+        <p159:morph option="byObject"/>
+      </p:transition>
+    </mc:Choice>
+    <mc:Fallback>
+      <p:transition spd="slow">
+        <p:fade/>
+      </p:transition>
+    </mc:Fallback>
+  </mc:AlternateContent>
 </p:sld>
 </file>
 
@@ -4219,6 +4305,7 @@
         <a:solidFill>
           <a:srgbClr val="6366F1"/>
         </a:solidFill>
+        <a:effectLst/>
       </p:bgPr>
     </p:bg>
     <p:spTree>
@@ -4256,6 +4343,13 @@
           </a:solidFill>
           <a:ln/>
         </p:spPr>
+        <p:txBody>
+          <a:bodyPr/>
+          <a:lstStyle/>
+          <a:p>
+            <a:endParaRPr lang="en-CH"/>
+          </a:p>
+        </p:txBody>
       </p:sp>
       <p:sp>
         <p:nvSpPr>
@@ -4278,6 +4372,13 @@
           </a:solidFill>
           <a:ln/>
         </p:spPr>
+        <p:txBody>
+          <a:bodyPr/>
+          <a:lstStyle/>
+          <a:p>
+            <a:endParaRPr lang="en-CH"/>
+          </a:p>
+        </p:txBody>
       </p:sp>
       <p:sp>
         <p:nvSpPr>
@@ -4300,11 +4401,11 @@
           <a:bodyPr wrap="square" rtlCol="0" anchor="ctr"/>
           <a:lstStyle/>
           <a:p>
-            <a:pPr algn="ctr" indent="0" marL="0">
-              <a:buNone/>
-            </a:pPr>
-            <a:r>
-              <a:rPr lang="en-US" sz="1200" b="1" spc="600" kern="0" dirty="0">
+            <a:pPr marL="0" indent="0" algn="ctr">
+              <a:buNone/>
+            </a:pPr>
+            <a:r>
+              <a:rPr lang="en-US" sz="1200" b="1" kern="0" spc="600" dirty="0">
                 <a:solidFill>
                   <a:srgbClr val="FFFFFF">
                     <a:alpha val="50000"/>
@@ -4341,7 +4442,7 @@
           <a:bodyPr wrap="square" rtlCol="0" anchor="ctr"/>
           <a:lstStyle/>
           <a:p>
-            <a:pPr algn="ctr" indent="0" marL="0">
+            <a:pPr marL="0" indent="0" algn="ctr">
               <a:lnSpc>
                 <a:spcPct val="150000"/>
               </a:lnSpc>
@@ -4361,7 +4462,7 @@
             <a:endParaRPr lang="en-US" sz="4000" dirty="0"/>
           </a:p>
           <a:p>
-            <a:pPr algn="ctr" indent="0" marL="0">
+            <a:pPr marL="0" indent="0" algn="ctr">
               <a:lnSpc>
                 <a:spcPct val="150000"/>
               </a:lnSpc>
@@ -4381,7 +4482,7 @@
             <a:endParaRPr lang="en-US" sz="4000" dirty="0"/>
           </a:p>
           <a:p>
-            <a:pPr algn="ctr" indent="0" marL="0">
+            <a:pPr marL="0" indent="0" algn="ctr">
               <a:lnSpc>
                 <a:spcPct val="150000"/>
               </a:lnSpc>
@@ -4423,7 +4524,7 @@
           <a:bodyPr wrap="square" rtlCol="0" anchor="ctr"/>
           <a:lstStyle/>
           <a:p>
-            <a:pPr algn="ctr" indent="0" marL="0">
+            <a:pPr marL="0" indent="0" algn="ctr">
               <a:buNone/>
             </a:pPr>
             <a:r>
@@ -4448,6 +4549,18 @@
   <p:clrMapOvr>
     <a:masterClrMapping/>
   </p:clrMapOvr>
+  <mc:AlternateContent xmlns:mc="http://schemas.openxmlformats.org/markup-compatibility/2006">
+    <mc:Choice xmlns:p159="http://schemas.microsoft.com/office/powerpoint/2015/09/main" Requires="p159">
+      <p:transition xmlns:p14="http://schemas.microsoft.com/office/powerpoint/2010/main" spd="slow" p14:dur="2000">
+        <p159:morph option="byObject"/>
+      </p:transition>
+    </mc:Choice>
+    <mc:Fallback>
+      <p:transition spd="slow">
+        <p:fade/>
+      </p:transition>
+    </mc:Fallback>
+  </mc:AlternateContent>
 </p:sld>
 </file>
 
@@ -4459,6 +4572,7 @@
         <a:solidFill>
           <a:srgbClr val="F8FAFC"/>
         </a:solidFill>
+        <a:effectLst/>
       </p:bgPr>
     </p:bg>
     <p:spTree>
@@ -4496,7 +4610,7 @@
           <a:bodyPr wrap="square" rtlCol="0" anchor="ctr"/>
           <a:lstStyle/>
           <a:p>
-            <a:pPr algn="ctr" indent="0" marL="0">
+            <a:pPr marL="0" indent="0" algn="ctr">
               <a:buNone/>
             </a:pPr>
             <a:r>
@@ -4535,6 +4649,13 @@
           </a:solidFill>
           <a:ln/>
         </p:spPr>
+        <p:txBody>
+          <a:bodyPr/>
+          <a:lstStyle/>
+          <a:p>
+            <a:endParaRPr lang="en-CH"/>
+          </a:p>
+        </p:txBody>
       </p:sp>
       <p:sp>
         <p:nvSpPr>
@@ -4555,6 +4676,13 @@
           </a:solidFill>
           <a:ln/>
         </p:spPr>
+        <p:txBody>
+          <a:bodyPr/>
+          <a:lstStyle/>
+          <a:p>
+            <a:endParaRPr lang="en-CH"/>
+          </a:p>
+        </p:txBody>
       </p:sp>
       <p:sp>
         <p:nvSpPr>
@@ -4577,7 +4705,7 @@
           <a:bodyPr wrap="square" rtlCol="0" anchor="ctr"/>
           <a:lstStyle/>
           <a:p>
-            <a:pPr algn="ctr" indent="0" marL="0">
+            <a:pPr marL="0" indent="0" algn="ctr">
               <a:buNone/>
             </a:pPr>
             <a:r>
@@ -4616,7 +4744,7 @@
           <a:bodyPr wrap="square" rtlCol="0" anchor="ctr"/>
           <a:lstStyle/>
           <a:p>
-            <a:pPr algn="ctr" indent="0" marL="0">
+            <a:pPr marL="0" indent="0" algn="ctr">
               <a:buNone/>
             </a:pPr>
             <a:r>
@@ -4655,7 +4783,7 @@
           <a:bodyPr wrap="square" rtlCol="0" anchor="ctr"/>
           <a:lstStyle/>
           <a:p>
-            <a:pPr algn="ctr" indent="0" marL="0">
+            <a:pPr marL="0" indent="0" algn="ctr">
               <a:lnSpc>
                 <a:spcPct val="130000"/>
               </a:lnSpc>
@@ -4697,7 +4825,7 @@
           <a:bodyPr wrap="square" rtlCol="0" anchor="ctr"/>
           <a:lstStyle/>
           <a:p>
-            <a:pPr algn="ctr" indent="0" marL="0">
+            <a:pPr marL="0" indent="0" algn="ctr">
               <a:buNone/>
             </a:pPr>
             <a:r>
@@ -4733,6 +4861,13 @@
           </a:solidFill>
           <a:ln/>
         </p:spPr>
+        <p:txBody>
+          <a:bodyPr/>
+          <a:lstStyle/>
+          <a:p>
+            <a:endParaRPr lang="en-CH"/>
+          </a:p>
+        </p:txBody>
       </p:sp>
       <p:sp>
         <p:nvSpPr>
@@ -4753,6 +4888,13 @@
           </a:solidFill>
           <a:ln/>
         </p:spPr>
+        <p:txBody>
+          <a:bodyPr/>
+          <a:lstStyle/>
+          <a:p>
+            <a:endParaRPr lang="en-CH"/>
+          </a:p>
+        </p:txBody>
       </p:sp>
       <p:sp>
         <p:nvSpPr>
@@ -4775,7 +4917,7 @@
           <a:bodyPr wrap="square" rtlCol="0" anchor="ctr"/>
           <a:lstStyle/>
           <a:p>
-            <a:pPr algn="ctr" indent="0" marL="0">
+            <a:pPr marL="0" indent="0" algn="ctr">
               <a:buNone/>
             </a:pPr>
             <a:r>
@@ -4814,7 +4956,7 @@
           <a:bodyPr wrap="square" rtlCol="0" anchor="ctr"/>
           <a:lstStyle/>
           <a:p>
-            <a:pPr algn="ctr" indent="0" marL="0">
+            <a:pPr marL="0" indent="0" algn="ctr">
               <a:buNone/>
             </a:pPr>
             <a:r>
@@ -4853,7 +4995,7 @@
           <a:bodyPr wrap="square" rtlCol="0" anchor="ctr"/>
           <a:lstStyle/>
           <a:p>
-            <a:pPr algn="ctr" indent="0" marL="0">
+            <a:pPr marL="0" indent="0" algn="ctr">
               <a:lnSpc>
                 <a:spcPct val="130000"/>
               </a:lnSpc>
@@ -4895,7 +5037,7 @@
           <a:bodyPr wrap="square" rtlCol="0" anchor="ctr"/>
           <a:lstStyle/>
           <a:p>
-            <a:pPr algn="ctr" indent="0" marL="0">
+            <a:pPr marL="0" indent="0" algn="ctr">
               <a:buNone/>
             </a:pPr>
             <a:r>
@@ -4931,6 +5073,13 @@
           </a:solidFill>
           <a:ln/>
         </p:spPr>
+        <p:txBody>
+          <a:bodyPr/>
+          <a:lstStyle/>
+          <a:p>
+            <a:endParaRPr lang="en-CH"/>
+          </a:p>
+        </p:txBody>
       </p:sp>
       <p:sp>
         <p:nvSpPr>
@@ -4951,6 +5100,13 @@
           </a:solidFill>
           <a:ln/>
         </p:spPr>
+        <p:txBody>
+          <a:bodyPr/>
+          <a:lstStyle/>
+          <a:p>
+            <a:endParaRPr lang="en-CH"/>
+          </a:p>
+        </p:txBody>
       </p:sp>
       <p:sp>
         <p:nvSpPr>
@@ -4973,7 +5129,7 @@
           <a:bodyPr wrap="square" rtlCol="0" anchor="ctr"/>
           <a:lstStyle/>
           <a:p>
-            <a:pPr algn="ctr" indent="0" marL="0">
+            <a:pPr marL="0" indent="0" algn="ctr">
               <a:buNone/>
             </a:pPr>
             <a:r>
@@ -5012,7 +5168,7 @@
           <a:bodyPr wrap="square" rtlCol="0" anchor="ctr"/>
           <a:lstStyle/>
           <a:p>
-            <a:pPr algn="ctr" indent="0" marL="0">
+            <a:pPr marL="0" indent="0" algn="ctr">
               <a:buNone/>
             </a:pPr>
             <a:r>
@@ -5051,7 +5207,7 @@
           <a:bodyPr wrap="square" rtlCol="0" anchor="ctr"/>
           <a:lstStyle/>
           <a:p>
-            <a:pPr algn="ctr" indent="0" marL="0">
+            <a:pPr marL="0" indent="0" algn="ctr">
               <a:lnSpc>
                 <a:spcPct val="130000"/>
               </a:lnSpc>
@@ -5093,7 +5249,7 @@
           <a:bodyPr wrap="square" rtlCol="0" anchor="ctr"/>
           <a:lstStyle/>
           <a:p>
-            <a:pPr algn="ctr" indent="0" marL="0">
+            <a:pPr marL="0" indent="0" algn="ctr">
               <a:buNone/>
             </a:pPr>
             <a:r>
@@ -5129,6 +5285,13 @@
           </a:solidFill>
           <a:ln/>
         </p:spPr>
+        <p:txBody>
+          <a:bodyPr/>
+          <a:lstStyle/>
+          <a:p>
+            <a:endParaRPr lang="en-CH"/>
+          </a:p>
+        </p:txBody>
       </p:sp>
       <p:sp>
         <p:nvSpPr>
@@ -5149,6 +5312,13 @@
           </a:solidFill>
           <a:ln/>
         </p:spPr>
+        <p:txBody>
+          <a:bodyPr/>
+          <a:lstStyle/>
+          <a:p>
+            <a:endParaRPr lang="en-CH"/>
+          </a:p>
+        </p:txBody>
       </p:sp>
       <p:sp>
         <p:nvSpPr>
@@ -5171,7 +5341,7 @@
           <a:bodyPr wrap="square" rtlCol="0" anchor="ctr"/>
           <a:lstStyle/>
           <a:p>
-            <a:pPr algn="ctr" indent="0" marL="0">
+            <a:pPr marL="0" indent="0" algn="ctr">
               <a:buNone/>
             </a:pPr>
             <a:r>
@@ -5210,7 +5380,7 @@
           <a:bodyPr wrap="square" rtlCol="0" anchor="ctr"/>
           <a:lstStyle/>
           <a:p>
-            <a:pPr algn="ctr" indent="0" marL="0">
+            <a:pPr marL="0" indent="0" algn="ctr">
               <a:buNone/>
             </a:pPr>
             <a:r>
@@ -5249,7 +5419,7 @@
           <a:bodyPr wrap="square" rtlCol="0" anchor="ctr"/>
           <a:lstStyle/>
           <a:p>
-            <a:pPr algn="ctr" indent="0" marL="0">
+            <a:pPr marL="0" indent="0" algn="ctr">
               <a:lnSpc>
                 <a:spcPct val="130000"/>
               </a:lnSpc>
@@ -5275,6 +5445,18 @@
   <p:clrMapOvr>
     <a:masterClrMapping/>
   </p:clrMapOvr>
+  <mc:AlternateContent xmlns:mc="http://schemas.openxmlformats.org/markup-compatibility/2006">
+    <mc:Choice xmlns:p159="http://schemas.microsoft.com/office/powerpoint/2015/09/main" Requires="p159">
+      <p:transition xmlns:p14="http://schemas.microsoft.com/office/powerpoint/2010/main" spd="slow" p14:dur="2000">
+        <p159:morph option="byObject"/>
+      </p:transition>
+    </mc:Choice>
+    <mc:Fallback>
+      <p:transition spd="slow">
+        <p:fade/>
+      </p:transition>
+    </mc:Fallback>
+  </mc:AlternateContent>
 </p:sld>
 </file>
 
@@ -5286,6 +5468,7 @@
         <a:solidFill>
           <a:srgbClr val="0F172A"/>
         </a:solidFill>
+        <a:effectLst/>
       </p:bgPr>
     </p:bg>
     <p:spTree>
@@ -5323,6 +5506,13 @@
           </a:solidFill>
           <a:ln/>
         </p:spPr>
+        <p:txBody>
+          <a:bodyPr/>
+          <a:lstStyle/>
+          <a:p>
+            <a:endParaRPr lang="en-CH"/>
+          </a:p>
+        </p:txBody>
       </p:sp>
       <p:sp>
         <p:nvSpPr>
@@ -5345,6 +5535,13 @@
           </a:solidFill>
           <a:ln/>
         </p:spPr>
+        <p:txBody>
+          <a:bodyPr/>
+          <a:lstStyle/>
+          <a:p>
+            <a:endParaRPr lang="en-CH"/>
+          </a:p>
+        </p:txBody>
       </p:sp>
       <p:sp>
         <p:nvSpPr>
@@ -5367,7 +5564,7 @@
           <a:bodyPr wrap="square" rtlCol="0" anchor="ctr"/>
           <a:lstStyle/>
           <a:p>
-            <a:pPr algn="ctr" indent="0" marL="0">
+            <a:pPr marL="0" indent="0" algn="ctr">
               <a:buNone/>
             </a:pPr>
             <a:r>
@@ -5408,6 +5605,13 @@
           </a:solidFill>
           <a:ln/>
         </p:spPr>
+        <p:txBody>
+          <a:bodyPr/>
+          <a:lstStyle/>
+          <a:p>
+            <a:endParaRPr lang="en-CH"/>
+          </a:p>
+        </p:txBody>
       </p:sp>
       <p:sp>
         <p:nvSpPr>
@@ -5437,6 +5641,13 @@
             <a:prstDash val="solid"/>
           </a:ln>
         </p:spPr>
+        <p:txBody>
+          <a:bodyPr/>
+          <a:lstStyle/>
+          <a:p>
+            <a:endParaRPr lang="en-CH"/>
+          </a:p>
+        </p:txBody>
       </p:sp>
       <p:sp>
         <p:nvSpPr>
@@ -5459,7 +5670,7 @@
           <a:bodyPr wrap="square" rtlCol="0" anchor="ctr"/>
           <a:lstStyle/>
           <a:p>
-            <a:pPr algn="ctr" indent="0" marL="0">
+            <a:pPr marL="0" indent="0" algn="ctr">
               <a:buNone/>
             </a:pPr>
             <a:r>
@@ -5498,7 +5709,7 @@
           <a:bodyPr wrap="square" rtlCol="0" anchor="ctr"/>
           <a:lstStyle/>
           <a:p>
-            <a:pPr algn="ctr" indent="0" marL="0">
+            <a:pPr marL="0" indent="0" algn="ctr">
               <a:buNone/>
             </a:pPr>
             <a:r>
@@ -5541,6 +5752,13 @@
           </a:solidFill>
           <a:ln/>
         </p:spPr>
+        <p:txBody>
+          <a:bodyPr/>
+          <a:lstStyle/>
+          <a:p>
+            <a:endParaRPr lang="en-CH"/>
+          </a:p>
+        </p:txBody>
       </p:sp>
       <p:sp>
         <p:nvSpPr>
@@ -5570,6 +5788,13 @@
             <a:prstDash val="solid"/>
           </a:ln>
         </p:spPr>
+        <p:txBody>
+          <a:bodyPr/>
+          <a:lstStyle/>
+          <a:p>
+            <a:endParaRPr lang="en-CH"/>
+          </a:p>
+        </p:txBody>
       </p:sp>
       <p:sp>
         <p:nvSpPr>
@@ -5592,7 +5817,7 @@
           <a:bodyPr wrap="square" rtlCol="0" anchor="ctr"/>
           <a:lstStyle/>
           <a:p>
-            <a:pPr algn="ctr" indent="0" marL="0">
+            <a:pPr marL="0" indent="0" algn="ctr">
               <a:buNone/>
             </a:pPr>
             <a:r>
@@ -5631,7 +5856,7 @@
           <a:bodyPr wrap="square" rtlCol="0" anchor="ctr"/>
           <a:lstStyle/>
           <a:p>
-            <a:pPr algn="ctr" indent="0" marL="0">
+            <a:pPr marL="0" indent="0" algn="ctr">
               <a:buNone/>
             </a:pPr>
             <a:r>
@@ -5674,6 +5899,13 @@
           </a:solidFill>
           <a:ln/>
         </p:spPr>
+        <p:txBody>
+          <a:bodyPr/>
+          <a:lstStyle/>
+          <a:p>
+            <a:endParaRPr lang="en-CH"/>
+          </a:p>
+        </p:txBody>
       </p:sp>
       <p:sp>
         <p:nvSpPr>
@@ -5703,6 +5935,13 @@
             <a:prstDash val="solid"/>
           </a:ln>
         </p:spPr>
+        <p:txBody>
+          <a:bodyPr/>
+          <a:lstStyle/>
+          <a:p>
+            <a:endParaRPr lang="en-CH"/>
+          </a:p>
+        </p:txBody>
       </p:sp>
       <p:sp>
         <p:nvSpPr>
@@ -5725,7 +5964,7 @@
           <a:bodyPr wrap="square" rtlCol="0" anchor="ctr"/>
           <a:lstStyle/>
           <a:p>
-            <a:pPr algn="ctr" indent="0" marL="0">
+            <a:pPr marL="0" indent="0" algn="ctr">
               <a:buNone/>
             </a:pPr>
             <a:r>
@@ -5764,7 +6003,7 @@
           <a:bodyPr wrap="square" rtlCol="0" anchor="ctr"/>
           <a:lstStyle/>
           <a:p>
-            <a:pPr algn="ctr" indent="0" marL="0">
+            <a:pPr marL="0" indent="0" algn="ctr">
               <a:buNone/>
             </a:pPr>
             <a:r>
@@ -5807,6 +6046,13 @@
           </a:solidFill>
           <a:ln/>
         </p:spPr>
+        <p:txBody>
+          <a:bodyPr/>
+          <a:lstStyle/>
+          <a:p>
+            <a:endParaRPr lang="en-CH"/>
+          </a:p>
+        </p:txBody>
       </p:sp>
       <p:sp>
         <p:nvSpPr>
@@ -5836,6 +6082,13 @@
             <a:prstDash val="solid"/>
           </a:ln>
         </p:spPr>
+        <p:txBody>
+          <a:bodyPr/>
+          <a:lstStyle/>
+          <a:p>
+            <a:endParaRPr lang="en-CH"/>
+          </a:p>
+        </p:txBody>
       </p:sp>
       <p:sp>
         <p:nvSpPr>
@@ -5858,7 +6111,7 @@
           <a:bodyPr wrap="square" rtlCol="0" anchor="ctr"/>
           <a:lstStyle/>
           <a:p>
-            <a:pPr algn="ctr" indent="0" marL="0">
+            <a:pPr marL="0" indent="0" algn="ctr">
               <a:buNone/>
             </a:pPr>
             <a:r>
@@ -5897,7 +6150,7 @@
           <a:bodyPr wrap="square" rtlCol="0" anchor="ctr"/>
           <a:lstStyle/>
           <a:p>
-            <a:pPr algn="ctr" indent="0" marL="0">
+            <a:pPr marL="0" indent="0" algn="ctr">
               <a:buNone/>
             </a:pPr>
             <a:r>
@@ -5922,6 +6175,18 @@
   <p:clrMapOvr>
     <a:masterClrMapping/>
   </p:clrMapOvr>
+  <mc:AlternateContent xmlns:mc="http://schemas.openxmlformats.org/markup-compatibility/2006">
+    <mc:Choice xmlns:p159="http://schemas.microsoft.com/office/powerpoint/2015/09/main" Requires="p159">
+      <p:transition xmlns:p14="http://schemas.microsoft.com/office/powerpoint/2010/main" spd="slow" p14:dur="2000">
+        <p159:morph option="byObject"/>
+      </p:transition>
+    </mc:Choice>
+    <mc:Fallback>
+      <p:transition spd="slow">
+        <p:fade/>
+      </p:transition>
+    </mc:Fallback>
+  </mc:AlternateContent>
 </p:sld>
 </file>
 
@@ -5933,6 +6198,7 @@
         <a:solidFill>
           <a:srgbClr val="F8FAFC"/>
         </a:solidFill>
+        <a:effectLst/>
       </p:bgPr>
     </p:bg>
     <p:spTree>
@@ -5970,7 +6236,7 @@
           <a:bodyPr wrap="square" rtlCol="0" anchor="ctr"/>
           <a:lstStyle/>
           <a:p>
-            <a:pPr algn="ctr" indent="0" marL="0">
+            <a:pPr marL="0" indent="0" algn="ctr">
               <a:buNone/>
             </a:pPr>
             <a:r>
@@ -6011,6 +6277,13 @@
           </a:solidFill>
           <a:ln/>
         </p:spPr>
+        <p:txBody>
+          <a:bodyPr/>
+          <a:lstStyle/>
+          <a:p>
+            <a:endParaRPr lang="en-CH"/>
+          </a:p>
+        </p:txBody>
       </p:sp>
       <p:sp>
         <p:nvSpPr>
@@ -6040,6 +6313,13 @@
             <a:prstDash val="solid"/>
           </a:ln>
         </p:spPr>
+        <p:txBody>
+          <a:bodyPr/>
+          <a:lstStyle/>
+          <a:p>
+            <a:endParaRPr lang="en-CH"/>
+          </a:p>
+        </p:txBody>
       </p:sp>
       <p:sp>
         <p:nvSpPr>
@@ -6062,7 +6342,7 @@
           <a:bodyPr wrap="square" rtlCol="0" anchor="ctr"/>
           <a:lstStyle/>
           <a:p>
-            <a:pPr algn="ctr" indent="0" marL="0">
+            <a:pPr marL="0" indent="0" algn="ctr">
               <a:buNone/>
             </a:pPr>
             <a:r>
@@ -6101,7 +6381,7 @@
           <a:bodyPr wrap="square" rtlCol="0" anchor="ctr"/>
           <a:lstStyle/>
           <a:p>
-            <a:pPr indent="0" marL="0">
+            <a:pPr marL="0" indent="0">
               <a:buNone/>
             </a:pPr>
             <a:r>
@@ -6140,7 +6420,7 @@
           <a:bodyPr wrap="square" rtlCol="0" anchor="ctr"/>
           <a:lstStyle/>
           <a:p>
-            <a:pPr indent="0" marL="0">
+            <a:pPr marL="0" indent="0">
               <a:buNone/>
             </a:pPr>
             <a:r>
@@ -6179,7 +6459,7 @@
           <a:bodyPr wrap="square" rtlCol="0" anchor="ctr"/>
           <a:lstStyle/>
           <a:p>
-            <a:pPr indent="0" marL="0">
+            <a:pPr marL="0" indent="0">
               <a:buNone/>
             </a:pPr>
             <a:r>
@@ -6218,7 +6498,7 @@
           <a:bodyPr wrap="square" rtlCol="0" anchor="ctr"/>
           <a:lstStyle/>
           <a:p>
-            <a:pPr indent="0" marL="0">
+            <a:pPr marL="0" indent="0">
               <a:buNone/>
             </a:pPr>
             <a:r>
@@ -6257,7 +6537,7 @@
           <a:bodyPr wrap="square" rtlCol="0" anchor="ctr"/>
           <a:lstStyle/>
           <a:p>
-            <a:pPr indent="0" marL="0">
+            <a:pPr marL="0" indent="0">
               <a:buNone/>
             </a:pPr>
             <a:r>
@@ -6298,6 +6578,13 @@
           </a:solidFill>
           <a:ln/>
         </p:spPr>
+        <p:txBody>
+          <a:bodyPr/>
+          <a:lstStyle/>
+          <a:p>
+            <a:endParaRPr lang="en-CH"/>
+          </a:p>
+        </p:txBody>
       </p:sp>
       <p:sp>
         <p:nvSpPr>
@@ -6327,6 +6614,13 @@
             <a:prstDash val="solid"/>
           </a:ln>
         </p:spPr>
+        <p:txBody>
+          <a:bodyPr/>
+          <a:lstStyle/>
+          <a:p>
+            <a:endParaRPr lang="en-CH"/>
+          </a:p>
+        </p:txBody>
       </p:sp>
       <p:sp>
         <p:nvSpPr>
@@ -6349,7 +6643,7 @@
           <a:bodyPr wrap="square" rtlCol="0" anchor="ctr"/>
           <a:lstStyle/>
           <a:p>
-            <a:pPr algn="ctr" indent="0" marL="0">
+            <a:pPr marL="0" indent="0" algn="ctr">
               <a:buNone/>
             </a:pPr>
             <a:r>
@@ -6388,7 +6682,7 @@
           <a:bodyPr wrap="square" rtlCol="0" anchor="ctr"/>
           <a:lstStyle/>
           <a:p>
-            <a:pPr indent="0" marL="0">
+            <a:pPr marL="0" indent="0">
               <a:buNone/>
             </a:pPr>
             <a:r>
@@ -6427,7 +6721,7 @@
           <a:bodyPr wrap="square" rtlCol="0" anchor="ctr"/>
           <a:lstStyle/>
           <a:p>
-            <a:pPr indent="0" marL="0">
+            <a:pPr marL="0" indent="0">
               <a:buNone/>
             </a:pPr>
             <a:r>
@@ -6466,7 +6760,7 @@
           <a:bodyPr wrap="square" rtlCol="0" anchor="ctr"/>
           <a:lstStyle/>
           <a:p>
-            <a:pPr indent="0" marL="0">
+            <a:pPr marL="0" indent="0">
               <a:buNone/>
             </a:pPr>
             <a:r>
@@ -6505,7 +6799,7 @@
           <a:bodyPr wrap="square" rtlCol="0" anchor="ctr"/>
           <a:lstStyle/>
           <a:p>
-            <a:pPr indent="0" marL="0">
+            <a:pPr marL="0" indent="0">
               <a:buNone/>
             </a:pPr>
             <a:r>
@@ -6544,7 +6838,7 @@
           <a:bodyPr wrap="square" rtlCol="0" anchor="ctr"/>
           <a:lstStyle/>
           <a:p>
-            <a:pPr indent="0" marL="0">
+            <a:pPr marL="0" indent="0">
               <a:buNone/>
             </a:pPr>
             <a:r>
@@ -6567,6 +6861,18 @@
   <p:clrMapOvr>
     <a:masterClrMapping/>
   </p:clrMapOvr>
+  <mc:AlternateContent xmlns:mc="http://schemas.openxmlformats.org/markup-compatibility/2006">
+    <mc:Choice xmlns:p159="http://schemas.microsoft.com/office/powerpoint/2015/09/main" Requires="p159">
+      <p:transition xmlns:p14="http://schemas.microsoft.com/office/powerpoint/2010/main" spd="slow" p14:dur="2000">
+        <p159:morph option="byObject"/>
+      </p:transition>
+    </mc:Choice>
+    <mc:Fallback>
+      <p:transition spd="slow">
+        <p:fade/>
+      </p:transition>
+    </mc:Fallback>
+  </mc:AlternateContent>
 </p:sld>
 </file>
 
@@ -6578,6 +6884,7 @@
         <a:solidFill>
           <a:srgbClr val="0F172A"/>
         </a:solidFill>
+        <a:effectLst/>
       </p:bgPr>
     </p:bg>
     <p:spTree>
@@ -6615,6 +6922,13 @@
           </a:solidFill>
           <a:ln/>
         </p:spPr>
+        <p:txBody>
+          <a:bodyPr/>
+          <a:lstStyle/>
+          <a:p>
+            <a:endParaRPr lang="en-CH"/>
+          </a:p>
+        </p:txBody>
       </p:sp>
       <p:sp>
         <p:nvSpPr>
@@ -6637,6 +6951,13 @@
           </a:solidFill>
           <a:ln/>
         </p:spPr>
+        <p:txBody>
+          <a:bodyPr/>
+          <a:lstStyle/>
+          <a:p>
+            <a:endParaRPr lang="en-CH"/>
+          </a:p>
+        </p:txBody>
       </p:sp>
       <p:sp>
         <p:nvSpPr>
@@ -6659,7 +6980,7 @@
           <a:bodyPr wrap="square" rtlCol="0" anchor="ctr"/>
           <a:lstStyle/>
           <a:p>
-            <a:pPr algn="ctr" indent="0" marL="0">
+            <a:pPr marL="0" indent="0" algn="ctr">
               <a:buNone/>
             </a:pPr>
             <a:r>
@@ -6700,6 +7021,13 @@
           </a:solidFill>
           <a:ln/>
         </p:spPr>
+        <p:txBody>
+          <a:bodyPr/>
+          <a:lstStyle/>
+          <a:p>
+            <a:endParaRPr lang="en-CH"/>
+          </a:p>
+        </p:txBody>
       </p:sp>
       <p:sp>
         <p:nvSpPr>
@@ -6729,6 +7057,13 @@
             <a:prstDash val="solid"/>
           </a:ln>
         </p:spPr>
+        <p:txBody>
+          <a:bodyPr/>
+          <a:lstStyle/>
+          <a:p>
+            <a:endParaRPr lang="en-CH"/>
+          </a:p>
+        </p:txBody>
       </p:sp>
       <p:sp>
         <p:nvSpPr>
@@ -6751,7 +7086,7 @@
           <a:bodyPr wrap="square" rtlCol="0" anchor="ctr"/>
           <a:lstStyle/>
           <a:p>
-            <a:pPr algn="ctr" indent="0" marL="0">
+            <a:pPr marL="0" indent="0" algn="ctr">
               <a:buNone/>
             </a:pPr>
             <a:r>
@@ -6790,7 +7125,7 @@
           <a:bodyPr wrap="square" rtlCol="0" anchor="ctr"/>
           <a:lstStyle/>
           <a:p>
-            <a:pPr algn="ctr" indent="0" marL="0">
+            <a:pPr marL="0" indent="0" algn="ctr">
               <a:buNone/>
             </a:pPr>
             <a:r>
@@ -6829,7 +7164,7 @@
           <a:bodyPr wrap="square" rtlCol="0" anchor="ctr"/>
           <a:lstStyle/>
           <a:p>
-            <a:pPr algn="ctr" indent="0" marL="0">
+            <a:pPr marL="0" indent="0" algn="ctr">
               <a:buNone/>
             </a:pPr>
             <a:r>
@@ -6870,7 +7205,7 @@
           <a:bodyPr wrap="square" rtlCol="0" anchor="ctr"/>
           <a:lstStyle/>
           <a:p>
-            <a:pPr indent="0" marL="0">
+            <a:pPr marL="0" indent="0">
               <a:buNone/>
             </a:pPr>
             <a:r>
@@ -6911,7 +7246,7 @@
           <a:bodyPr wrap="square" rtlCol="0" anchor="ctr"/>
           <a:lstStyle/>
           <a:p>
-            <a:pPr indent="0" marL="0">
+            <a:pPr marL="0" indent="0">
               <a:buNone/>
             </a:pPr>
             <a:r>
@@ -6952,7 +7287,7 @@
           <a:bodyPr wrap="square" rtlCol="0" anchor="ctr"/>
           <a:lstStyle/>
           <a:p>
-            <a:pPr indent="0" marL="0">
+            <a:pPr marL="0" indent="0">
               <a:buNone/>
             </a:pPr>
             <a:r>
@@ -6993,7 +7328,7 @@
           <a:bodyPr wrap="square" rtlCol="0" anchor="ctr"/>
           <a:lstStyle/>
           <a:p>
-            <a:pPr indent="0" marL="0">
+            <a:pPr marL="0" indent="0">
               <a:buNone/>
             </a:pPr>
             <a:r>
@@ -7036,6 +7371,13 @@
           </a:solidFill>
           <a:ln/>
         </p:spPr>
+        <p:txBody>
+          <a:bodyPr/>
+          <a:lstStyle/>
+          <a:p>
+            <a:endParaRPr lang="en-CH"/>
+          </a:p>
+        </p:txBody>
       </p:sp>
       <p:sp>
         <p:nvSpPr>
@@ -7065,6 +7407,13 @@
             <a:prstDash val="solid"/>
           </a:ln>
         </p:spPr>
+        <p:txBody>
+          <a:bodyPr/>
+          <a:lstStyle/>
+          <a:p>
+            <a:endParaRPr lang="en-CH"/>
+          </a:p>
+        </p:txBody>
       </p:sp>
       <p:sp>
         <p:nvSpPr>
@@ -7087,6 +7436,13 @@
           </a:solidFill>
           <a:ln/>
         </p:spPr>
+        <p:txBody>
+          <a:bodyPr/>
+          <a:lstStyle/>
+          <a:p>
+            <a:endParaRPr lang="en-CH"/>
+          </a:p>
+        </p:txBody>
       </p:sp>
       <p:sp>
         <p:nvSpPr>
@@ -7109,7 +7465,7 @@
           <a:bodyPr wrap="square" rtlCol="0" anchor="ctr"/>
           <a:lstStyle/>
           <a:p>
-            <a:pPr algn="ctr" indent="0" marL="0">
+            <a:pPr marL="0" indent="0" algn="ctr">
               <a:buNone/>
             </a:pPr>
             <a:r>
@@ -7148,7 +7504,7 @@
           <a:bodyPr wrap="square" rtlCol="0" anchor="ctr"/>
           <a:lstStyle/>
           <a:p>
-            <a:pPr algn="ctr" indent="0" marL="0">
+            <a:pPr marL="0" indent="0" algn="ctr">
               <a:buNone/>
             </a:pPr>
             <a:r>
@@ -7187,7 +7543,7 @@
           <a:bodyPr wrap="square" rtlCol="0" anchor="ctr"/>
           <a:lstStyle/>
           <a:p>
-            <a:pPr algn="ctr" indent="0" marL="0">
+            <a:pPr marL="0" indent="0" algn="ctr">
               <a:buNone/>
             </a:pPr>
             <a:r>
@@ -7226,7 +7582,7 @@
           <a:bodyPr wrap="square" rtlCol="0" anchor="ctr"/>
           <a:lstStyle/>
           <a:p>
-            <a:pPr algn="ctr" indent="0" marL="0">
+            <a:pPr marL="0" indent="0" algn="ctr">
               <a:buNone/>
             </a:pPr>
             <a:r>
@@ -7267,7 +7623,7 @@
           <a:bodyPr wrap="square" rtlCol="0" anchor="ctr"/>
           <a:lstStyle/>
           <a:p>
-            <a:pPr indent="0" marL="0">
+            <a:pPr marL="0" indent="0">
               <a:buNone/>
             </a:pPr>
             <a:r>
@@ -7306,7 +7662,7 @@
           <a:bodyPr wrap="square" rtlCol="0" anchor="ctr"/>
           <a:lstStyle/>
           <a:p>
-            <a:pPr indent="0" marL="0">
+            <a:pPr marL="0" indent="0">
               <a:buNone/>
             </a:pPr>
             <a:r>
@@ -7345,7 +7701,7 @@
           <a:bodyPr wrap="square" rtlCol="0" anchor="ctr"/>
           <a:lstStyle/>
           <a:p>
-            <a:pPr indent="0" marL="0">
+            <a:pPr marL="0" indent="0">
               <a:buNone/>
             </a:pPr>
             <a:r>
@@ -7384,7 +7740,7 @@
           <a:bodyPr wrap="square" rtlCol="0" anchor="ctr"/>
           <a:lstStyle/>
           <a:p>
-            <a:pPr indent="0" marL="0">
+            <a:pPr marL="0" indent="0">
               <a:buNone/>
             </a:pPr>
             <a:r>
@@ -7425,6 +7781,13 @@
           </a:solidFill>
           <a:ln/>
         </p:spPr>
+        <p:txBody>
+          <a:bodyPr/>
+          <a:lstStyle/>
+          <a:p>
+            <a:endParaRPr lang="en-CH"/>
+          </a:p>
+        </p:txBody>
       </p:sp>
       <p:sp>
         <p:nvSpPr>
@@ -7454,6 +7817,13 @@
             <a:prstDash val="solid"/>
           </a:ln>
         </p:spPr>
+        <p:txBody>
+          <a:bodyPr/>
+          <a:lstStyle/>
+          <a:p>
+            <a:endParaRPr lang="en-CH"/>
+          </a:p>
+        </p:txBody>
       </p:sp>
       <p:sp>
         <p:nvSpPr>
@@ -7476,7 +7846,7 @@
           <a:bodyPr wrap="square" rtlCol="0" anchor="ctr"/>
           <a:lstStyle/>
           <a:p>
-            <a:pPr algn="ctr" indent="0" marL="0">
+            <a:pPr marL="0" indent="0" algn="ctr">
               <a:buNone/>
             </a:pPr>
             <a:r>
@@ -7515,7 +7885,7 @@
           <a:bodyPr wrap="square" rtlCol="0" anchor="ctr"/>
           <a:lstStyle/>
           <a:p>
-            <a:pPr algn="ctr" indent="0" marL="0">
+            <a:pPr marL="0" indent="0" algn="ctr">
               <a:buNone/>
             </a:pPr>
             <a:r>
@@ -7554,7 +7924,7 @@
           <a:bodyPr wrap="square" rtlCol="0" anchor="ctr"/>
           <a:lstStyle/>
           <a:p>
-            <a:pPr algn="ctr" indent="0" marL="0">
+            <a:pPr marL="0" indent="0" algn="ctr">
               <a:buNone/>
             </a:pPr>
             <a:r>
@@ -7595,7 +7965,7 @@
           <a:bodyPr wrap="square" rtlCol="0" anchor="ctr"/>
           <a:lstStyle/>
           <a:p>
-            <a:pPr indent="0" marL="0">
+            <a:pPr marL="0" indent="0">
               <a:buNone/>
             </a:pPr>
             <a:r>
@@ -7636,7 +8006,7 @@
           <a:bodyPr wrap="square" rtlCol="0" anchor="ctr"/>
           <a:lstStyle/>
           <a:p>
-            <a:pPr indent="0" marL="0">
+            <a:pPr marL="0" indent="0">
               <a:buNone/>
             </a:pPr>
             <a:r>
@@ -7677,7 +8047,7 @@
           <a:bodyPr wrap="square" rtlCol="0" anchor="ctr"/>
           <a:lstStyle/>
           <a:p>
-            <a:pPr indent="0" marL="0">
+            <a:pPr marL="0" indent="0">
               <a:buNone/>
             </a:pPr>
             <a:r>
@@ -7718,7 +8088,7 @@
           <a:bodyPr wrap="square" rtlCol="0" anchor="ctr"/>
           <a:lstStyle/>
           <a:p>
-            <a:pPr indent="0" marL="0">
+            <a:pPr marL="0" indent="0">
               <a:buNone/>
             </a:pPr>
             <a:r>
@@ -7759,7 +8129,7 @@
           <a:bodyPr wrap="square" rtlCol="0" anchor="ctr"/>
           <a:lstStyle/>
           <a:p>
-            <a:pPr algn="ctr" indent="0" marL="0">
+            <a:pPr marL="0" indent="0" algn="ctr">
               <a:buNone/>
             </a:pPr>
             <a:r>
@@ -7782,6 +8152,18 @@
   <p:clrMapOvr>
     <a:masterClrMapping/>
   </p:clrMapOvr>
+  <mc:AlternateContent xmlns:mc="http://schemas.openxmlformats.org/markup-compatibility/2006">
+    <mc:Choice xmlns:p159="http://schemas.microsoft.com/office/powerpoint/2015/09/main" Requires="p159">
+      <p:transition xmlns:p14="http://schemas.microsoft.com/office/powerpoint/2010/main" spd="slow" p14:dur="2000">
+        <p159:morph option="byObject"/>
+      </p:transition>
+    </mc:Choice>
+    <mc:Fallback>
+      <p:transition spd="slow">
+        <p:fade/>
+      </p:transition>
+    </mc:Fallback>
+  </mc:AlternateContent>
 </p:sld>
 </file>
 
@@ -8078,4 +8460,319 @@
     </a:ext>
   </a:extLst>
 </a:theme>
+</file>
+
+<file path=ppt/theme/theme2.xml><?xml version="1.0" encoding="utf-8"?>
+<a:theme xmlns:a="http://schemas.openxmlformats.org/drawingml/2006/main" name="Office Theme">
+  <a:themeElements>
+    <a:clrScheme name="Office">
+      <a:dk1>
+        <a:sysClr val="windowText" lastClr="000000"/>
+      </a:dk1>
+      <a:lt1>
+        <a:sysClr val="window" lastClr="FFFFFF"/>
+      </a:lt1>
+      <a:dk2>
+        <a:srgbClr val="0E2841"/>
+      </a:dk2>
+      <a:lt2>
+        <a:srgbClr val="E8E8E8"/>
+      </a:lt2>
+      <a:accent1>
+        <a:srgbClr val="156082"/>
+      </a:accent1>
+      <a:accent2>
+        <a:srgbClr val="E97132"/>
+      </a:accent2>
+      <a:accent3>
+        <a:srgbClr val="196B24"/>
+      </a:accent3>
+      <a:accent4>
+        <a:srgbClr val="0F9ED5"/>
+      </a:accent4>
+      <a:accent5>
+        <a:srgbClr val="A02B93"/>
+      </a:accent5>
+      <a:accent6>
+        <a:srgbClr val="4EA72E"/>
+      </a:accent6>
+      <a:hlink>
+        <a:srgbClr val="467886"/>
+      </a:hlink>
+      <a:folHlink>
+        <a:srgbClr val="96607D"/>
+      </a:folHlink>
+    </a:clrScheme>
+    <a:fontScheme name="Office">
+      <a:majorFont>
+        <a:latin typeface="Aptos Display" panose="02110004020202020204"/>
+        <a:ea typeface=""/>
+        <a:cs typeface=""/>
+        <a:font script="Jpan" typeface="游ゴシック Light"/>
+        <a:font script="Hang" typeface="맑은 고딕"/>
+        <a:font script="Hans" typeface="等线 Light"/>
+        <a:font script="Hant" typeface="新細明體"/>
+        <a:font script="Arab" typeface="Times New Roman"/>
+        <a:font script="Hebr" typeface="Times New Roman"/>
+        <a:font script="Thai" typeface="Angsana New"/>
+        <a:font script="Ethi" typeface="Nyala"/>
+        <a:font script="Beng" typeface="Vrinda"/>
+        <a:font script="Gujr" typeface="Shruti"/>
+        <a:font script="Khmr" typeface="MoolBoran"/>
+        <a:font script="Knda" typeface="Tunga"/>
+        <a:font script="Guru" typeface="Raavi"/>
+        <a:font script="Cans" typeface="Euphemia"/>
+        <a:font script="Cher" typeface="Plantagenet Cherokee"/>
+        <a:font script="Yiii" typeface="Microsoft Yi Baiti"/>
+        <a:font script="Tibt" typeface="Microsoft Himalaya"/>
+        <a:font script="Thaa" typeface="MV Boli"/>
+        <a:font script="Deva" typeface="Mangal"/>
+        <a:font script="Telu" typeface="Gautami"/>
+        <a:font script="Taml" typeface="Latha"/>
+        <a:font script="Syrc" typeface="Estrangelo Edessa"/>
+        <a:font script="Orya" typeface="Kalinga"/>
+        <a:font script="Mlym" typeface="Kartika"/>
+        <a:font script="Laoo" typeface="DokChampa"/>
+        <a:font script="Sinh" typeface="Iskoola Pota"/>
+        <a:font script="Mong" typeface="Mongolian Baiti"/>
+        <a:font script="Viet" typeface="Times New Roman"/>
+        <a:font script="Uigh" typeface="Microsoft Uighur"/>
+        <a:font script="Geor" typeface="Sylfaen"/>
+        <a:font script="Armn" typeface="Arial"/>
+        <a:font script="Bugi" typeface="Leelawadee UI"/>
+        <a:font script="Bopo" typeface="Microsoft JhengHei"/>
+        <a:font script="Java" typeface="Javanese Text"/>
+        <a:font script="Lisu" typeface="Segoe UI"/>
+        <a:font script="Mymr" typeface="Myanmar Text"/>
+        <a:font script="Nkoo" typeface="Ebrima"/>
+        <a:font script="Olck" typeface="Nirmala UI"/>
+        <a:font script="Osma" typeface="Ebrima"/>
+        <a:font script="Phag" typeface="Phagspa"/>
+        <a:font script="Syrn" typeface="Estrangelo Edessa"/>
+        <a:font script="Syrj" typeface="Estrangelo Edessa"/>
+        <a:font script="Syre" typeface="Estrangelo Edessa"/>
+        <a:font script="Sora" typeface="Nirmala UI"/>
+        <a:font script="Tale" typeface="Microsoft Tai Le"/>
+        <a:font script="Talu" typeface="Microsoft New Tai Lue"/>
+        <a:font script="Tfng" typeface="Ebrima"/>
+      </a:majorFont>
+      <a:minorFont>
+        <a:latin typeface="Aptos" panose="02110004020202020204"/>
+        <a:ea typeface=""/>
+        <a:cs typeface=""/>
+        <a:font script="Jpan" typeface="游ゴシック"/>
+        <a:font script="Hang" typeface="맑은 고딕"/>
+        <a:font script="Hans" typeface="等线"/>
+        <a:font script="Hant" typeface="新細明體"/>
+        <a:font script="Arab" typeface="Arial"/>
+        <a:font script="Hebr" typeface="Arial"/>
+        <a:font script="Thai" typeface="Cordia New"/>
+        <a:font script="Ethi" typeface="Nyala"/>
+        <a:font script="Beng" typeface="Vrinda"/>
+        <a:font script="Gujr" typeface="Shruti"/>
+        <a:font script="Khmr" typeface="DaunPenh"/>
+        <a:font script="Knda" typeface="Tunga"/>
+        <a:font script="Guru" typeface="Raavi"/>
+        <a:font script="Cans" typeface="Euphemia"/>
+        <a:font script="Cher" typeface="Plantagenet Cherokee"/>
+        <a:font script="Yiii" typeface="Microsoft Yi Baiti"/>
+        <a:font script="Tibt" typeface="Microsoft Himalaya"/>
+        <a:font script="Thaa" typeface="MV Boli"/>
+        <a:font script="Deva" typeface="Mangal"/>
+        <a:font script="Telu" typeface="Gautami"/>
+        <a:font script="Taml" typeface="Latha"/>
+        <a:font script="Syrc" typeface="Estrangelo Edessa"/>
+        <a:font script="Orya" typeface="Kalinga"/>
+        <a:font script="Mlym" typeface="Kartika"/>
+        <a:font script="Laoo" typeface="DokChampa"/>
+        <a:font script="Sinh" typeface="Iskoola Pota"/>
+        <a:font script="Mong" typeface="Mongolian Baiti"/>
+        <a:font script="Viet" typeface="Arial"/>
+        <a:font script="Uigh" typeface="Microsoft Uighur"/>
+        <a:font script="Geor" typeface="Sylfaen"/>
+        <a:font script="Armn" typeface="Arial"/>
+        <a:font script="Bugi" typeface="Leelawadee UI"/>
+        <a:font script="Bopo" typeface="Microsoft JhengHei"/>
+        <a:font script="Java" typeface="Javanese Text"/>
+        <a:font script="Lisu" typeface="Segoe UI"/>
+        <a:font script="Mymr" typeface="Myanmar Text"/>
+        <a:font script="Nkoo" typeface="Ebrima"/>
+        <a:font script="Olck" typeface="Nirmala UI"/>
+        <a:font script="Osma" typeface="Ebrima"/>
+        <a:font script="Phag" typeface="Phagspa"/>
+        <a:font script="Syrn" typeface="Estrangelo Edessa"/>
+        <a:font script="Syrj" typeface="Estrangelo Edessa"/>
+        <a:font script="Syre" typeface="Estrangelo Edessa"/>
+        <a:font script="Sora" typeface="Nirmala UI"/>
+        <a:font script="Tale" typeface="Microsoft Tai Le"/>
+        <a:font script="Talu" typeface="Microsoft New Tai Lue"/>
+        <a:font script="Tfng" typeface="Ebrima"/>
+      </a:minorFont>
+    </a:fontScheme>
+    <a:fmtScheme name="Office">
+      <a:fillStyleLst>
+        <a:solidFill>
+          <a:schemeClr val="phClr"/>
+        </a:solidFill>
+        <a:gradFill rotWithShape="1">
+          <a:gsLst>
+            <a:gs pos="0">
+              <a:schemeClr val="phClr">
+                <a:lumMod val="110000"/>
+                <a:satMod val="105000"/>
+                <a:tint val="67000"/>
+              </a:schemeClr>
+            </a:gs>
+            <a:gs pos="50000">
+              <a:schemeClr val="phClr">
+                <a:lumMod val="105000"/>
+                <a:satMod val="103000"/>
+                <a:tint val="73000"/>
+              </a:schemeClr>
+            </a:gs>
+            <a:gs pos="100000">
+              <a:schemeClr val="phClr">
+                <a:lumMod val="105000"/>
+                <a:satMod val="109000"/>
+                <a:tint val="81000"/>
+              </a:schemeClr>
+            </a:gs>
+          </a:gsLst>
+          <a:lin ang="5400000" scaled="0"/>
+        </a:gradFill>
+        <a:gradFill rotWithShape="1">
+          <a:gsLst>
+            <a:gs pos="0">
+              <a:schemeClr val="phClr">
+                <a:satMod val="103000"/>
+                <a:lumMod val="102000"/>
+                <a:tint val="94000"/>
+              </a:schemeClr>
+            </a:gs>
+            <a:gs pos="50000">
+              <a:schemeClr val="phClr">
+                <a:satMod val="110000"/>
+                <a:lumMod val="100000"/>
+                <a:shade val="100000"/>
+              </a:schemeClr>
+            </a:gs>
+            <a:gs pos="100000">
+              <a:schemeClr val="phClr">
+                <a:lumMod val="99000"/>
+                <a:satMod val="120000"/>
+                <a:shade val="78000"/>
+              </a:schemeClr>
+            </a:gs>
+          </a:gsLst>
+          <a:lin ang="5400000" scaled="0"/>
+        </a:gradFill>
+      </a:fillStyleLst>
+      <a:lnStyleLst>
+        <a:ln w="12700" cap="flat" cmpd="sng" algn="ctr">
+          <a:solidFill>
+            <a:schemeClr val="phClr"/>
+          </a:solidFill>
+          <a:prstDash val="solid"/>
+          <a:miter lim="800000"/>
+        </a:ln>
+        <a:ln w="19050" cap="flat" cmpd="sng" algn="ctr">
+          <a:solidFill>
+            <a:schemeClr val="phClr"/>
+          </a:solidFill>
+          <a:prstDash val="solid"/>
+          <a:miter lim="800000"/>
+        </a:ln>
+        <a:ln w="25400" cap="flat" cmpd="sng" algn="ctr">
+          <a:solidFill>
+            <a:schemeClr val="phClr"/>
+          </a:solidFill>
+          <a:prstDash val="solid"/>
+          <a:miter lim="800000"/>
+        </a:ln>
+      </a:lnStyleLst>
+      <a:effectStyleLst>
+        <a:effectStyle>
+          <a:effectLst/>
+        </a:effectStyle>
+        <a:effectStyle>
+          <a:effectLst/>
+        </a:effectStyle>
+        <a:effectStyle>
+          <a:effectLst>
+            <a:outerShdw blurRad="57150" dist="19050" dir="5400000" algn="ctr" rotWithShape="0">
+              <a:srgbClr val="000000">
+                <a:alpha val="63000"/>
+              </a:srgbClr>
+            </a:outerShdw>
+          </a:effectLst>
+        </a:effectStyle>
+      </a:effectStyleLst>
+      <a:bgFillStyleLst>
+        <a:solidFill>
+          <a:schemeClr val="phClr"/>
+        </a:solidFill>
+        <a:solidFill>
+          <a:schemeClr val="phClr">
+            <a:tint val="95000"/>
+            <a:satMod val="170000"/>
+          </a:schemeClr>
+        </a:solidFill>
+        <a:gradFill rotWithShape="1">
+          <a:gsLst>
+            <a:gs pos="0">
+              <a:schemeClr val="phClr">
+                <a:tint val="93000"/>
+                <a:satMod val="150000"/>
+                <a:shade val="98000"/>
+                <a:lumMod val="102000"/>
+              </a:schemeClr>
+            </a:gs>
+            <a:gs pos="50000">
+              <a:schemeClr val="phClr">
+                <a:tint val="98000"/>
+                <a:satMod val="130000"/>
+                <a:shade val="90000"/>
+                <a:lumMod val="103000"/>
+              </a:schemeClr>
+            </a:gs>
+            <a:gs pos="100000">
+              <a:schemeClr val="phClr">
+                <a:shade val="63000"/>
+                <a:satMod val="120000"/>
+              </a:schemeClr>
+            </a:gs>
+          </a:gsLst>
+          <a:lin ang="5400000" scaled="0"/>
+        </a:gradFill>
+      </a:bgFillStyleLst>
+    </a:fmtScheme>
+  </a:themeElements>
+  <a:objectDefaults>
+    <a:lnDef>
+      <a:spPr/>
+      <a:bodyPr/>
+      <a:lstStyle/>
+      <a:style>
+        <a:lnRef idx="2">
+          <a:schemeClr val="accent1"/>
+        </a:lnRef>
+        <a:fillRef idx="0">
+          <a:schemeClr val="accent1"/>
+        </a:fillRef>
+        <a:effectRef idx="1">
+          <a:schemeClr val="accent1"/>
+        </a:effectRef>
+        <a:fontRef idx="minor">
+          <a:schemeClr val="tx1"/>
+        </a:fontRef>
+      </a:style>
+    </a:lnDef>
+  </a:objectDefaults>
+  <a:extraClrSchemeLst/>
+  <a:extLst>
+    <a:ext uri="{05A4C25C-085E-4340-85A3-A5531E510DB2}">
+      <thm15:themeFamily xmlns:thm15="http://schemas.microsoft.com/office/thememl/2012/main" name="Office Theme" id="{2E142A2C-CD16-42D6-873A-C26D2A0506FA}" vid="{1BDDFF52-6CD6-40A5-AB3C-68EB2F1E4D0A}"/>
+    </a:ext>
+  </a:extLst>
+</a:theme>
 </file>
</xml_diff>